<commit_message>
Week 2: add Excel cheat sheet, rewrite in plainer voice, recolor slides
</commit_message>
<xml_diff>
--- a/week-02-excel/slides/week-02-slides.pptx
+++ b/week-02-excel/slides/week-02-slides.pptx
@@ -12,10 +12,9 @@
     <p:sldId id="260" r:id="rId6"/>
     <p:sldId id="261" r:id="rId7"/>
     <p:sldId id="262" r:id="rId8"/>
-    <p:sldId id="263" r:id="rId9"/>
   </p:sldIdLst>
   <p:notesMasterIdLst>
-    <p:notesMasterId r:id="rId10"/>
+    <p:notesMasterId r:id="rId9"/>
   </p:notesMasterIdLst>
   <p:sldSz cx="12192000" cy="6858000"/>
   <p:notesSz cx="6858000" cy="12192000"/>
@@ -1061,94 +1060,6 @@
             <a:fld id="{F7021451-1387-4CA6-816F-3879F97B5CBC}" type="slidenum">
               <a:rPr lang="en-US"/>
               <a:t>7</a:t>
-            </a:fld>
-            <a:endParaRPr lang="en-US"/>
-          </a:p>
-        </p:txBody>
-      </p:sp>
-    </p:spTree>
-    <p:extLst>
-      <p:ext uri="{BB962C8B-B14F-4D97-AF65-F5344CB8AC3E}">
-        <p14:creationId xmlns:p14="http://schemas.microsoft.com/office/powerpoint/2010/main" val="1024086991"/>
-      </p:ext>
-    </p:extLst>
-  </p:cSld>
-  <p:clrMapOvr>
-    <a:masterClrMapping/>
-  </p:clrMapOvr>
-</p:notes>
-</file>
-
-<file path=ppt/notesSlides/notesSlide8.xml><?xml version="1.0" encoding="utf-8"?>
-<p:notes xmlns:a="http://schemas.openxmlformats.org/drawingml/2006/main" xmlns:r="http://schemas.openxmlformats.org/officeDocument/2006/relationships" xmlns:p="http://schemas.openxmlformats.org/presentationml/2006/main">
-  <p:cSld>
-    <p:spTree>
-      <p:nvGrpSpPr>
-        <p:cNvPr id="1" name=""/>
-        <p:cNvGrpSpPr/>
-        <p:nvPr/>
-      </p:nvGrpSpPr>
-      <p:grpSpPr>
-        <a:xfrm>
-          <a:off x="0" y="0"/>
-          <a:ext cx="0" cy="0"/>
-          <a:chOff x="0" y="0"/>
-          <a:chExt cx="0" cy="0"/>
-        </a:xfrm>
-      </p:grpSpPr>
-      <p:sp>
-        <p:nvSpPr>
-          <p:cNvPr id="2" name="Slide Image Placeholder 1"/>
-          <p:cNvSpPr>
-            <a:spLocks noGrp="1" noRot="1" noChangeAspect="1"/>
-          </p:cNvSpPr>
-          <p:nvPr>
-            <p:ph type="sldImg"/>
-          </p:nvPr>
-        </p:nvSpPr>
-        <p:spPr/>
-      </p:sp>
-      <p:sp>
-        <p:nvSpPr>
-          <p:cNvPr id="3" name="Notes Placeholder 2"/>
-          <p:cNvSpPr>
-            <a:spLocks noGrp="1"/>
-          </p:cNvSpPr>
-          <p:nvPr>
-            <p:ph type="body" idx="1"/>
-          </p:nvPr>
-        </p:nvSpPr>
-        <p:spPr/>
-        <p:txBody>
-          <a:bodyPr/>
-          <a:lstStyle/>
-          <a:p>
-            <a:r>
-              <a:rPr lang="en-US" dirty="0"/>
-              <a:t/>
-            </a:r>
-            <a:endParaRPr lang="en-US" dirty="0"/>
-          </a:p>
-        </p:txBody>
-      </p:sp>
-      <p:sp>
-        <p:nvSpPr>
-          <p:cNvPr id="4" name="Slide Number Placeholder 3"/>
-          <p:cNvSpPr>
-            <a:spLocks noGrp="1"/>
-          </p:cNvSpPr>
-          <p:nvPr>
-            <p:ph type="sldNum" sz="quarter" idx="10"/>
-          </p:nvPr>
-        </p:nvSpPr>
-        <p:spPr/>
-        <p:txBody>
-          <a:bodyPr/>
-          <a:lstStyle/>
-          <a:p>
-            <a:fld id="{F7021451-1387-4CA6-816F-3879F97B5CBC}" type="slidenum">
-              <a:rPr lang="en-US"/>
-              <a:t>8</a:t>
             </a:fld>
             <a:endParaRPr lang="en-US"/>
           </a:p>
@@ -1480,7 +1391,7 @@
     <p:bg>
       <p:bgPr>
         <a:solidFill>
-          <a:srgbClr val="1B3A34"/>
+          <a:srgbClr val="1C3F60"/>
         </a:solidFill>
       </p:bgPr>
     </p:bg>
@@ -1545,7 +1456,7 @@
         </p:nvSpPr>
         <p:spPr>
           <a:xfrm>
-            <a:off x="640080" y="2377440"/>
+            <a:off x="640080" y="2286000"/>
             <a:ext cx="10515600" cy="1645920"/>
           </a:xfrm>
           <a:prstGeom prst="rect">
@@ -1601,7 +1512,7 @@
         </p:nvSpPr>
         <p:spPr>
           <a:xfrm>
-            <a:off x="640080" y="3749040"/>
+            <a:off x="640080" y="3657600"/>
             <a:ext cx="10058400" cy="731520"/>
           </a:xfrm>
           <a:prstGeom prst="rect">
@@ -1620,7 +1531,7 @@
             <a:r>
               <a:rPr lang="en-US" sz="1800" dirty="0">
                 <a:solidFill>
-                  <a:srgbClr val="D8E4E0"/>
+                  <a:srgbClr val="D6E2EA"/>
                 </a:solidFill>
                 <a:latin typeface="Calibri" pitchFamily="34" charset="0"/>
                 <a:ea typeface="Calibri" pitchFamily="34" charset="-122"/>
@@ -1640,7 +1551,7 @@
         </p:nvSpPr>
         <p:spPr>
           <a:xfrm>
-            <a:off x="640080" y="2148840"/>
+            <a:off x="640080" y="2057400"/>
             <a:ext cx="1280160" cy="45720"/>
           </a:xfrm>
           <a:prstGeom prst="rect">
@@ -1750,7 +1661,7 @@
             <a:r>
               <a:rPr lang="en-US" sz="2700" b="1" dirty="0">
                 <a:solidFill>
-                  <a:srgbClr val="1B3A34"/>
+                  <a:srgbClr val="1C3F60"/>
                 </a:solidFill>
                 <a:latin typeface="Georgia" pitchFamily="34" charset="0"/>
                 <a:ea typeface="Georgia" pitchFamily="34" charset="-122"/>
@@ -1770,8 +1681,8 @@
         </p:nvSpPr>
         <p:spPr>
           <a:xfrm>
-            <a:off x="640080" y="1920240"/>
-            <a:ext cx="10515600" cy="731520"/>
+            <a:off x="640080" y="1828800"/>
+            <a:ext cx="10515600" cy="640080"/>
           </a:xfrm>
           <a:prstGeom prst="rect">
             <a:avLst/>
@@ -1787,7 +1698,7 @@
               <a:buNone/>
             </a:pPr>
             <a:r>
-              <a:rPr lang="en-US" sz="1700" dirty="0">
+              <a:rPr lang="en-US" sz="1600" dirty="0">
                 <a:solidFill>
                   <a:srgbClr val="2A2A2A"/>
                 </a:solidFill>
@@ -1795,9 +1706,9 @@
                 <a:ea typeface="Calibri" pitchFamily="34" charset="-122"/>
                 <a:cs typeface="Calibri" pitchFamily="34" charset="-120"/>
               </a:rPr>
-              <a:t>Real outcomes for 173 college majors — pulled from an actual national survey, not a tutorial dataset.</a:t>
-            </a:r>
-            <a:endParaRPr lang="en-US" sz="1700" dirty="0"/>
+              <a:t>173 college majors. Real employment and salary outcomes from an actual national survey — not a tutorial dataset.</a:t>
+            </a:r>
+            <a:endParaRPr lang="en-US" sz="1600" dirty="0"/>
           </a:p>
         </p:txBody>
       </p:sp>
@@ -1809,8 +1720,8 @@
         </p:nvSpPr>
         <p:spPr>
           <a:xfrm>
-            <a:off x="640080" y="2834640"/>
-            <a:ext cx="2377440" cy="1005840"/>
+            <a:off x="640080" y="2697480"/>
+            <a:ext cx="3291840" cy="914400"/>
           </a:xfrm>
           <a:prstGeom prst="rect">
             <a:avLst/>
@@ -1822,11 +1733,11 @@
           <a:bodyPr wrap="square" rtlCol="0" anchor="ctr"/>
           <a:lstStyle/>
           <a:p>
-            <a:pPr algn="l" indent="0" marL="0">
-              <a:buNone/>
-            </a:pPr>
-            <a:r>
-              <a:rPr lang="en-US" sz="4400" b="1" dirty="0">
+            <a:pPr indent="0" marL="0">
+              <a:buNone/>
+            </a:pPr>
+            <a:r>
+              <a:rPr lang="en-US" sz="3800" b="1" dirty="0">
                 <a:solidFill>
                   <a:srgbClr val="D97E3F"/>
                 </a:solidFill>
@@ -1836,7 +1747,7 @@
               </a:rPr>
               <a:t>173</a:t>
             </a:r>
-            <a:endParaRPr lang="en-US" sz="4400" dirty="0"/>
+            <a:endParaRPr lang="en-US" sz="3800" dirty="0"/>
           </a:p>
         </p:txBody>
       </p:sp>
@@ -1848,8 +1759,8 @@
         </p:nvSpPr>
         <p:spPr>
           <a:xfrm>
-            <a:off x="640080" y="3794760"/>
-            <a:ext cx="2377440" cy="640080"/>
+            <a:off x="640080" y="3566160"/>
+            <a:ext cx="3291840" cy="731520"/>
           </a:xfrm>
           <a:prstGeom prst="rect">
             <a:avLst/>
@@ -1887,8 +1798,8 @@
         </p:nvSpPr>
         <p:spPr>
           <a:xfrm>
-            <a:off x="3291840" y="2834640"/>
-            <a:ext cx="2377440" cy="1005840"/>
+            <a:off x="4206240" y="2697480"/>
+            <a:ext cx="3291840" cy="914400"/>
           </a:xfrm>
           <a:prstGeom prst="rect">
             <a:avLst/>
@@ -1900,11 +1811,11 @@
           <a:bodyPr wrap="square" rtlCol="0" anchor="ctr"/>
           <a:lstStyle/>
           <a:p>
-            <a:pPr algn="l" indent="0" marL="0">
-              <a:buNone/>
-            </a:pPr>
-            <a:r>
-              <a:rPr lang="en-US" sz="4400" b="1" dirty="0">
+            <a:pPr indent="0" marL="0">
+              <a:buNone/>
+            </a:pPr>
+            <a:r>
+              <a:rPr lang="en-US" sz="3800" b="1" dirty="0">
                 <a:solidFill>
                   <a:srgbClr val="D97E3F"/>
                 </a:solidFill>
@@ -1914,7 +1825,7 @@
               </a:rPr>
               <a:t>21</a:t>
             </a:r>
-            <a:endParaRPr lang="en-US" sz="4400" dirty="0"/>
+            <a:endParaRPr lang="en-US" sz="3800" dirty="0"/>
           </a:p>
         </p:txBody>
       </p:sp>
@@ -1926,8 +1837,8 @@
         </p:nvSpPr>
         <p:spPr>
           <a:xfrm>
-            <a:off x="3291840" y="3794760"/>
-            <a:ext cx="2377440" cy="640080"/>
+            <a:off x="4206240" y="3566160"/>
+            <a:ext cx="3291840" cy="731520"/>
           </a:xfrm>
           <a:prstGeom prst="rect">
             <a:avLst/>
@@ -1965,8 +1876,8 @@
         </p:nvSpPr>
         <p:spPr>
           <a:xfrm>
-            <a:off x="5943600" y="2834640"/>
-            <a:ext cx="2377440" cy="1005840"/>
+            <a:off x="7772400" y="2697480"/>
+            <a:ext cx="3291840" cy="914400"/>
           </a:xfrm>
           <a:prstGeom prst="rect">
             <a:avLst/>
@@ -1978,11 +1889,11 @@
           <a:bodyPr wrap="square" rtlCol="0" anchor="ctr"/>
           <a:lstStyle/>
           <a:p>
-            <a:pPr algn="l" indent="0" marL="0">
-              <a:buNone/>
-            </a:pPr>
-            <a:r>
-              <a:rPr lang="en-US" sz="4400" b="1" dirty="0">
+            <a:pPr indent="0" marL="0">
+              <a:buNone/>
+            </a:pPr>
+            <a:r>
+              <a:rPr lang="en-US" sz="3800" b="1" dirty="0">
                 <a:solidFill>
                   <a:srgbClr val="D97E3F"/>
                 </a:solidFill>
@@ -1990,9 +1901,9 @@
                 <a:ea typeface="Georgia" pitchFamily="34" charset="-122"/>
                 <a:cs typeface="Georgia" pitchFamily="34" charset="-120"/>
               </a:rPr>
-              <a:t>16</a:t>
-            </a:r>
-            <a:endParaRPr lang="en-US" sz="4400" dirty="0"/>
+              <a:t>2–4,212</a:t>
+            </a:r>
+            <a:endParaRPr lang="en-US" sz="3800" dirty="0"/>
           </a:p>
         </p:txBody>
       </p:sp>
@@ -2004,8 +1915,8 @@
         </p:nvSpPr>
         <p:spPr>
           <a:xfrm>
-            <a:off x="5943600" y="3794760"/>
-            <a:ext cx="2377440" cy="640080"/>
+            <a:off x="7772400" y="3566160"/>
+            <a:ext cx="3291840" cy="731520"/>
           </a:xfrm>
           <a:prstGeom prst="rect">
             <a:avLst/>
@@ -2029,71 +1940,10 @@
                 <a:ea typeface="Calibri" pitchFamily="34" charset="-122"/>
                 <a:cs typeface="Calibri" pitchFamily="34" charset="-120"/>
               </a:rPr>
-              <a:t>major categories</a:t>
+              <a:t>range of Sample_size —</a:t>
             </a:r>
             <a:endParaRPr lang="en-US" sz="1300" dirty="0"/>
           </a:p>
-        </p:txBody>
-      </p:sp>
-      <p:sp>
-        <p:nvSpPr>
-          <p:cNvPr id="11" name="Text 9"/>
-          <p:cNvSpPr/>
-          <p:nvPr/>
-        </p:nvSpPr>
-        <p:spPr>
-          <a:xfrm>
-            <a:off x="8595360" y="2834640"/>
-            <a:ext cx="2377440" cy="1005840"/>
-          </a:xfrm>
-          <a:prstGeom prst="rect">
-            <a:avLst/>
-          </a:prstGeom>
-          <a:noFill/>
-          <a:ln/>
-        </p:spPr>
-        <p:txBody>
-          <a:bodyPr wrap="square" rtlCol="0" anchor="ctr"/>
-          <a:lstStyle/>
-          <a:p>
-            <a:pPr algn="l" indent="0" marL="0">
-              <a:buNone/>
-            </a:pPr>
-            <a:r>
-              <a:rPr lang="en-US" sz="4400" b="1" dirty="0">
-                <a:solidFill>
-                  <a:srgbClr val="D97E3F"/>
-                </a:solidFill>
-                <a:latin typeface="Georgia" pitchFamily="34" charset="0"/>
-                <a:ea typeface="Georgia" pitchFamily="34" charset="-122"/>
-                <a:cs typeface="Georgia" pitchFamily="34" charset="-120"/>
-              </a:rPr>
-              <a:t>1</a:t>
-            </a:r>
-            <a:endParaRPr lang="en-US" sz="4400" dirty="0"/>
-          </a:p>
-        </p:txBody>
-      </p:sp>
-      <p:sp>
-        <p:nvSpPr>
-          <p:cNvPr id="12" name="Text 10"/>
-          <p:cNvSpPr/>
-          <p:nvPr/>
-        </p:nvSpPr>
-        <p:spPr>
-          <a:xfrm>
-            <a:off x="8595360" y="3794760"/>
-            <a:ext cx="2377440" cy="640080"/>
-          </a:xfrm>
-          <a:prstGeom prst="rect">
-            <a:avLst/>
-          </a:prstGeom>
-          <a:noFill/>
-          <a:ln/>
-        </p:spPr>
-        <p:txBody>
-          <a:bodyPr wrap="square" rtlCol="0" anchor="ctr"/>
-          <a:lstStyle/>
           <a:p>
             <a:pPr indent="0" marL="0">
               <a:buNone/>
@@ -2107,65 +1957,68 @@
                 <a:ea typeface="Calibri" pitchFamily="34" charset="-122"/>
                 <a:cs typeface="Calibri" pitchFamily="34" charset="-120"/>
               </a:rPr>
-              <a:t>genuinely debatable</a:t>
+              <a:t>small means less reliable</a:t>
             </a:r>
             <a:endParaRPr lang="en-US" sz="1300" dirty="0"/>
           </a:p>
-          <a:p>
-            <a:pPr indent="0" marL="0">
-              <a:buNone/>
-            </a:pPr>
-            <a:r>
-              <a:rPr lang="en-US" sz="1300" dirty="0">
-                <a:solidFill>
-                  <a:srgbClr val="6B6B6B"/>
+        </p:txBody>
+      </p:sp>
+      <p:sp>
+        <p:nvSpPr>
+          <p:cNvPr id="11" name="Shape 9"/>
+          <p:cNvSpPr/>
+          <p:nvPr/>
+        </p:nvSpPr>
+        <p:spPr>
+          <a:xfrm>
+            <a:off x="640080" y="4663440"/>
+            <a:ext cx="10881360" cy="1005840"/>
+          </a:xfrm>
+          <a:prstGeom prst="rect">
+            <a:avLst/>
+          </a:prstGeom>
+          <a:solidFill>
+            <a:srgbClr val="F4F1EC"/>
+          </a:solidFill>
+          <a:ln/>
+        </p:spPr>
+      </p:sp>
+      <p:sp>
+        <p:nvSpPr>
+          <p:cNvPr id="12" name="Text 10"/>
+          <p:cNvSpPr/>
+          <p:nvPr/>
+        </p:nvSpPr>
+        <p:spPr>
+          <a:xfrm>
+            <a:off x="914400" y="4846320"/>
+            <a:ext cx="10332720" cy="640080"/>
+          </a:xfrm>
+          <a:prstGeom prst="rect">
+            <a:avLst/>
+          </a:prstGeom>
+          <a:noFill/>
+          <a:ln/>
+        </p:spPr>
+        <p:txBody>
+          <a:bodyPr wrap="square" rtlCol="0" anchor="ctr"/>
+          <a:lstStyle/>
+          <a:p>
+            <a:pPr indent="0" marL="0">
+              <a:buNone/>
+            </a:pPr>
+            <a:r>
+              <a:rPr lang="en-US" sz="1350" dirty="0">
+                <a:solidFill>
+                  <a:srgbClr val="2A2A2A"/>
                 </a:solidFill>
                 <a:latin typeface="Calibri" pitchFamily="34" charset="0"/>
                 <a:ea typeface="Calibri" pitchFamily="34" charset="-122"/>
                 <a:cs typeface="Calibri" pitchFamily="34" charset="-120"/>
               </a:rPr>
-              <a:t>relationship inside</a:t>
-            </a:r>
-            <a:endParaRPr lang="en-US" sz="1300" dirty="0"/>
-          </a:p>
-        </p:txBody>
-      </p:sp>
-      <p:sp>
-        <p:nvSpPr>
-          <p:cNvPr id="13" name="Text 11"/>
-          <p:cNvSpPr/>
-          <p:nvPr/>
-        </p:nvSpPr>
-        <p:spPr>
-          <a:xfrm>
-            <a:off x="640080" y="5212080"/>
-            <a:ext cx="10058400" cy="548640"/>
-          </a:xfrm>
-          <a:prstGeom prst="rect">
-            <a:avLst/>
-          </a:prstGeom>
-          <a:noFill/>
-          <a:ln/>
-        </p:spPr>
-        <p:txBody>
-          <a:bodyPr wrap="square" rtlCol="0" anchor="ctr"/>
-          <a:lstStyle/>
-          <a:p>
-            <a:pPr indent="0" marL="0">
-              <a:buNone/>
-            </a:pPr>
-            <a:r>
-              <a:rPr lang="en-US" sz="1400" i="1" dirty="0">
-                <a:solidFill>
-                  <a:srgbClr val="2A2A2A"/>
-                </a:solidFill>
-                <a:latin typeface="Calibri" pitchFamily="34" charset="0"/>
-                <a:ea typeface="Calibri" pitchFamily="34" charset="-122"/>
-                <a:cs typeface="Calibri" pitchFamily="34" charset="-120"/>
-              </a:rPr>
-              <a:t>By the end of today you'll have an opinion, backed by a number, about something in here.</a:t>
-            </a:r>
-            <a:endParaRPr lang="en-US" sz="1400" dirty="0"/>
+              <a:t>32 of 173 majors have a sample under 30. A major's salary figure and its reliability are two different questions — check the data dictionary before you trust either.</a:t>
+            </a:r>
+            <a:endParaRPr lang="en-US" sz="1350" dirty="0"/>
           </a:p>
         </p:txBody>
       </p:sp>
@@ -2234,7 +2087,7 @@
                 <a:ea typeface="Calibri" pitchFamily="34" charset="-122"/>
                 <a:cs typeface="Calibri" pitchFamily="34" charset="-120"/>
               </a:rPr>
-              <a:t>BEFORE YOU TRUST A NUMBER</a:t>
+              <a:t>CORE EXCEL MOVES</a:t>
             </a:r>
             <a:endParaRPr lang="en-US" sz="1200" dirty="0"/>
           </a:p>
@@ -2267,13 +2120,13 @@
             <a:r>
               <a:rPr lang="en-US" sz="2700" b="1" dirty="0">
                 <a:solidFill>
-                  <a:srgbClr val="1B3A34"/>
+                  <a:srgbClr val="1C3F60"/>
                 </a:solidFill>
                 <a:latin typeface="Georgia" pitchFamily="34" charset="0"/>
                 <a:ea typeface="Georgia" pitchFamily="34" charset="-122"/>
                 <a:cs typeface="Georgia" pitchFamily="34" charset="-120"/>
               </a:rPr>
-              <a:t>Read the data dictionary first</a:t>
+              <a:t>One question, one tool, in order</a:t>
             </a:r>
             <a:endParaRPr lang="en-US" sz="2700" dirty="0"/>
           </a:p>
@@ -2288,7 +2141,7 @@
         <p:spPr>
           <a:xfrm>
             <a:off x="640080" y="2011680"/>
-            <a:ext cx="10058400" cy="640080"/>
+            <a:ext cx="548640" cy="548640"/>
           </a:xfrm>
           <a:prstGeom prst="rect">
             <a:avLst/>
@@ -2304,115 +2157,327 @@
               <a:buNone/>
             </a:pPr>
             <a:r>
-              <a:rPr lang="en-US" sz="2000" b="1" dirty="0">
-                <a:solidFill>
-                  <a:srgbClr val="1B3A34"/>
+              <a:rPr lang="en-US" sz="2400" b="1" dirty="0">
+                <a:solidFill>
+                  <a:srgbClr val="D97E3F"/>
                 </a:solidFill>
                 <a:latin typeface="Georgia" pitchFamily="34" charset="0"/>
                 <a:ea typeface="Georgia" pitchFamily="34" charset="-122"/>
                 <a:cs typeface="Georgia" pitchFamily="34" charset="-120"/>
               </a:rPr>
-              <a:t>Sample_size ranges from 2 to 4,212 across these 173 rows.</a:t>
-            </a:r>
-            <a:endParaRPr lang="en-US" sz="2000" dirty="0"/>
-          </a:p>
-        </p:txBody>
-      </p:sp>
-      <p:sp>
-        <p:nvSpPr>
-          <p:cNvPr id="5" name="Shape 3"/>
-          <p:cNvSpPr/>
-          <p:nvPr/>
-        </p:nvSpPr>
-        <p:spPr>
-          <a:xfrm>
-            <a:off x="640080" y="2834640"/>
-            <a:ext cx="10881360" cy="2377440"/>
-          </a:xfrm>
-          <a:prstGeom prst="roundRect">
-            <a:avLst>
-              <a:gd name="adj" fmla="val 2308"/>
-            </a:avLst>
-          </a:prstGeom>
-          <a:solidFill>
-            <a:srgbClr val="F4F1EC"/>
-          </a:solidFill>
-          <a:ln/>
-        </p:spPr>
-      </p:sp>
-      <p:sp>
-        <p:nvSpPr>
-          <p:cNvPr id="6" name="Text 4"/>
-          <p:cNvSpPr/>
-          <p:nvPr/>
-        </p:nvSpPr>
-        <p:spPr>
-          <a:xfrm>
-            <a:off x="1005840" y="3108960"/>
-            <a:ext cx="10149840" cy="731520"/>
-          </a:xfrm>
-          <a:prstGeom prst="rect">
-            <a:avLst/>
-          </a:prstGeom>
-          <a:noFill/>
-          <a:ln/>
-        </p:spPr>
-        <p:txBody>
-          <a:bodyPr wrap="square" rtlCol="0" anchor="ctr"/>
-          <a:lstStyle/>
-          <a:p>
-            <a:pPr indent="0" marL="0">
-              <a:buNone/>
-            </a:pPr>
-            <a:r>
-              <a:rPr lang="en-US" sz="1500" dirty="0">
-                <a:solidFill>
-                  <a:srgbClr val="2A2A2A"/>
+              <a:t>1</a:t>
+            </a:r>
+            <a:endParaRPr lang="en-US" sz="2400" dirty="0"/>
+          </a:p>
+        </p:txBody>
+      </p:sp>
+      <p:sp>
+        <p:nvSpPr>
+          <p:cNvPr id="5" name="Text 3"/>
+          <p:cNvSpPr/>
+          <p:nvPr/>
+        </p:nvSpPr>
+        <p:spPr>
+          <a:xfrm>
+            <a:off x="1280160" y="1993392"/>
+            <a:ext cx="2743200" cy="1097280"/>
+          </a:xfrm>
+          <a:prstGeom prst="rect">
+            <a:avLst/>
+          </a:prstGeom>
+          <a:noFill/>
+          <a:ln/>
+        </p:spPr>
+        <p:txBody>
+          <a:bodyPr wrap="square" rtlCol="0" anchor="t"/>
+          <a:lstStyle/>
+          <a:p>
+            <a:pPr indent="0" marL="0">
+              <a:buNone/>
+            </a:pPr>
+            <a:r>
+              <a:rPr lang="en-US" sz="1600" b="1" dirty="0">
+                <a:solidFill>
+                  <a:srgbClr val="1C3F60"/>
                 </a:solidFill>
                 <a:latin typeface="Calibri" pitchFamily="34" charset="0"/>
                 <a:ea typeface="Calibri" pitchFamily="34" charset="-122"/>
                 <a:cs typeface="Calibri" pitchFamily="34" charset="-120"/>
               </a:rPr>
-              <a:t>32 of 173 majors have a sample under 30 — the standard cutoff for trusting a summary statistic. One is based on a sample of 2.</a:t>
-            </a:r>
-            <a:endParaRPr lang="en-US" sz="1500" dirty="0"/>
-          </a:p>
-        </p:txBody>
-      </p:sp>
-      <p:sp>
-        <p:nvSpPr>
-          <p:cNvPr id="7" name="Text 5"/>
-          <p:cNvSpPr/>
-          <p:nvPr/>
-        </p:nvSpPr>
-        <p:spPr>
-          <a:xfrm>
-            <a:off x="1005840" y="3977640"/>
-            <a:ext cx="10149840" cy="1005840"/>
-          </a:xfrm>
-          <a:prstGeom prst="rect">
-            <a:avLst/>
-          </a:prstGeom>
-          <a:noFill/>
-          <a:ln/>
-        </p:spPr>
-        <p:txBody>
-          <a:bodyPr wrap="square" rtlCol="0" anchor="ctr"/>
-          <a:lstStyle/>
-          <a:p>
-            <a:pPr indent="0" marL="0">
-              <a:buNone/>
-            </a:pPr>
-            <a:r>
-              <a:rPr lang="en-US" sz="1400" i="1" dirty="0">
-                <a:solidFill>
-                  <a:srgbClr val="6B6B6B"/>
+              <a:t>Sort &amp; filter</a:t>
+            </a:r>
+            <a:endParaRPr lang="en-US" sz="1600" dirty="0"/>
+          </a:p>
+        </p:txBody>
+      </p:sp>
+      <p:sp>
+        <p:nvSpPr>
+          <p:cNvPr id="6" name="Text 4"/>
+          <p:cNvSpPr/>
+          <p:nvPr/>
+        </p:nvSpPr>
+        <p:spPr>
+          <a:xfrm>
+            <a:off x="4206240" y="1993392"/>
+            <a:ext cx="7223760" cy="1097280"/>
+          </a:xfrm>
+          <a:prstGeom prst="rect">
+            <a:avLst/>
+          </a:prstGeom>
+          <a:noFill/>
+          <a:ln/>
+        </p:spPr>
+        <p:txBody>
+          <a:bodyPr wrap="square" rtlCol="0" anchor="t"/>
+          <a:lstStyle/>
+          <a:p>
+            <a:pPr indent="0" marL="0">
+              <a:buNone/>
+            </a:pPr>
+            <a:r>
+              <a:rPr lang="en-US" sz="1400" dirty="0">
+                <a:solidFill>
+                  <a:srgbClr val="2A2A2A"/>
                 </a:solidFill>
                 <a:latin typeface="Calibri" pitchFamily="34" charset="0"/>
                 <a:ea typeface="Calibri" pitchFamily="34" charset="-122"/>
                 <a:cs typeface="Calibri" pitchFamily="34" charset="-120"/>
               </a:rPr>
-              <a:t>A major's salary figure and its reliability are two different questions. A real dataset makes you decide how much to trust it — a cleaned classroom dataset never asks.</a:t>
+              <a:t>Highest unemployment rate — still trust it once you check Sample_size?</a:t>
+            </a:r>
+            <a:endParaRPr lang="en-US" sz="1400" dirty="0"/>
+          </a:p>
+        </p:txBody>
+      </p:sp>
+      <p:sp>
+        <p:nvSpPr>
+          <p:cNvPr id="7" name="Text 5"/>
+          <p:cNvSpPr/>
+          <p:nvPr/>
+        </p:nvSpPr>
+        <p:spPr>
+          <a:xfrm>
+            <a:off x="640080" y="3246120"/>
+            <a:ext cx="548640" cy="548640"/>
+          </a:xfrm>
+          <a:prstGeom prst="rect">
+            <a:avLst/>
+          </a:prstGeom>
+          <a:noFill/>
+          <a:ln/>
+        </p:spPr>
+        <p:txBody>
+          <a:bodyPr wrap="square" rtlCol="0" anchor="ctr"/>
+          <a:lstStyle/>
+          <a:p>
+            <a:pPr indent="0" marL="0">
+              <a:buNone/>
+            </a:pPr>
+            <a:r>
+              <a:rPr lang="en-US" sz="2400" b="1" dirty="0">
+                <a:solidFill>
+                  <a:srgbClr val="D97E3F"/>
+                </a:solidFill>
+                <a:latin typeface="Georgia" pitchFamily="34" charset="0"/>
+                <a:ea typeface="Georgia" pitchFamily="34" charset="-122"/>
+                <a:cs typeface="Georgia" pitchFamily="34" charset="-120"/>
+              </a:rPr>
+              <a:t>2</a:t>
+            </a:r>
+            <a:endParaRPr lang="en-US" sz="2400" dirty="0"/>
+          </a:p>
+        </p:txBody>
+      </p:sp>
+      <p:sp>
+        <p:nvSpPr>
+          <p:cNvPr id="8" name="Text 6"/>
+          <p:cNvSpPr/>
+          <p:nvPr/>
+        </p:nvSpPr>
+        <p:spPr>
+          <a:xfrm>
+            <a:off x="1280160" y="3227832"/>
+            <a:ext cx="2743200" cy="1097280"/>
+          </a:xfrm>
+          <a:prstGeom prst="rect">
+            <a:avLst/>
+          </a:prstGeom>
+          <a:noFill/>
+          <a:ln/>
+        </p:spPr>
+        <p:txBody>
+          <a:bodyPr wrap="square" rtlCol="0" anchor="t"/>
+          <a:lstStyle/>
+          <a:p>
+            <a:pPr indent="0" marL="0">
+              <a:buNone/>
+            </a:pPr>
+            <a:r>
+              <a:rPr lang="en-US" sz="1600" b="1" dirty="0">
+                <a:solidFill>
+                  <a:srgbClr val="1C3F60"/>
+                </a:solidFill>
+                <a:latin typeface="Calibri" pitchFamily="34" charset="0"/>
+                <a:ea typeface="Calibri" pitchFamily="34" charset="-122"/>
+                <a:cs typeface="Calibri" pitchFamily="34" charset="-120"/>
+              </a:rPr>
+              <a:t>A calculated column</a:t>
+            </a:r>
+            <a:endParaRPr lang="en-US" sz="1600" dirty="0"/>
+          </a:p>
+        </p:txBody>
+      </p:sp>
+      <p:sp>
+        <p:nvSpPr>
+          <p:cNvPr id="9" name="Text 7"/>
+          <p:cNvSpPr/>
+          <p:nvPr/>
+        </p:nvSpPr>
+        <p:spPr>
+          <a:xfrm>
+            <a:off x="4206240" y="3227832"/>
+            <a:ext cx="7223760" cy="1097280"/>
+          </a:xfrm>
+          <a:prstGeom prst="rect">
+            <a:avLst/>
+          </a:prstGeom>
+          <a:noFill/>
+          <a:ln/>
+        </p:spPr>
+        <p:txBody>
+          <a:bodyPr wrap="square" rtlCol="0" anchor="t"/>
+          <a:lstStyle/>
+          <a:p>
+            <a:pPr indent="0" marL="0">
+              <a:buNone/>
+            </a:pPr>
+            <a:r>
+              <a:rPr lang="en-US" sz="1400" dirty="0">
+                <a:solidFill>
+                  <a:srgbClr val="2A2A2A"/>
+                </a:solidFill>
+                <a:latin typeface="Calibri" pitchFamily="34" charset="0"/>
+                <a:ea typeface="Calibri" pitchFamily="34" charset="-122"/>
+                <a:cs typeface="Calibri" pitchFamily="34" charset="-120"/>
+              </a:rPr>
+              <a:t>How many graduates end up outside their field? Build Underemployment_rate.</a:t>
+            </a:r>
+            <a:endParaRPr lang="en-US" sz="1400" dirty="0"/>
+          </a:p>
+        </p:txBody>
+      </p:sp>
+      <p:sp>
+        <p:nvSpPr>
+          <p:cNvPr id="10" name="Text 8"/>
+          <p:cNvSpPr/>
+          <p:nvPr/>
+        </p:nvSpPr>
+        <p:spPr>
+          <a:xfrm>
+            <a:off x="640080" y="4480560"/>
+            <a:ext cx="548640" cy="548640"/>
+          </a:xfrm>
+          <a:prstGeom prst="rect">
+            <a:avLst/>
+          </a:prstGeom>
+          <a:noFill/>
+          <a:ln/>
+        </p:spPr>
+        <p:txBody>
+          <a:bodyPr wrap="square" rtlCol="0" anchor="ctr"/>
+          <a:lstStyle/>
+          <a:p>
+            <a:pPr indent="0" marL="0">
+              <a:buNone/>
+            </a:pPr>
+            <a:r>
+              <a:rPr lang="en-US" sz="2400" b="1" dirty="0">
+                <a:solidFill>
+                  <a:srgbClr val="D97E3F"/>
+                </a:solidFill>
+                <a:latin typeface="Georgia" pitchFamily="34" charset="0"/>
+                <a:ea typeface="Georgia" pitchFamily="34" charset="-122"/>
+                <a:cs typeface="Georgia" pitchFamily="34" charset="-120"/>
+              </a:rPr>
+              <a:t>3</a:t>
+            </a:r>
+            <a:endParaRPr lang="en-US" sz="2400" dirty="0"/>
+          </a:p>
+        </p:txBody>
+      </p:sp>
+      <p:sp>
+        <p:nvSpPr>
+          <p:cNvPr id="11" name="Text 9"/>
+          <p:cNvSpPr/>
+          <p:nvPr/>
+        </p:nvSpPr>
+        <p:spPr>
+          <a:xfrm>
+            <a:off x="1280160" y="4462272"/>
+            <a:ext cx="2743200" cy="1097280"/>
+          </a:xfrm>
+          <a:prstGeom prst="rect">
+            <a:avLst/>
+          </a:prstGeom>
+          <a:noFill/>
+          <a:ln/>
+        </p:spPr>
+        <p:txBody>
+          <a:bodyPr wrap="square" rtlCol="0" anchor="t"/>
+          <a:lstStyle/>
+          <a:p>
+            <a:pPr indent="0" marL="0">
+              <a:buNone/>
+            </a:pPr>
+            <a:r>
+              <a:rPr lang="en-US" sz="1600" b="1" dirty="0">
+                <a:solidFill>
+                  <a:srgbClr val="1C3F60"/>
+                </a:solidFill>
+                <a:latin typeface="Calibri" pitchFamily="34" charset="0"/>
+                <a:ea typeface="Calibri" pitchFamily="34" charset="-122"/>
+                <a:cs typeface="Calibri" pitchFamily="34" charset="-120"/>
+              </a:rPr>
+              <a:t>Pivot table</a:t>
+            </a:r>
+            <a:endParaRPr lang="en-US" sz="1600" dirty="0"/>
+          </a:p>
+        </p:txBody>
+      </p:sp>
+      <p:sp>
+        <p:nvSpPr>
+          <p:cNvPr id="12" name="Text 10"/>
+          <p:cNvSpPr/>
+          <p:nvPr/>
+        </p:nvSpPr>
+        <p:spPr>
+          <a:xfrm>
+            <a:off x="4206240" y="4462272"/>
+            <a:ext cx="7223760" cy="1097280"/>
+          </a:xfrm>
+          <a:prstGeom prst="rect">
+            <a:avLst/>
+          </a:prstGeom>
+          <a:noFill/>
+          <a:ln/>
+        </p:spPr>
+        <p:txBody>
+          <a:bodyPr wrap="square" rtlCol="0" anchor="t"/>
+          <a:lstStyle/>
+          <a:p>
+            <a:pPr indent="0" marL="0">
+              <a:buNone/>
+            </a:pPr>
+            <a:r>
+              <a:rPr lang="en-US" sz="1400" dirty="0">
+                <a:solidFill>
+                  <a:srgbClr val="2A2A2A"/>
+                </a:solidFill>
+                <a:latin typeface="Calibri" pitchFamily="34" charset="0"/>
+                <a:ea typeface="Calibri" pitchFamily="34" charset="-122"/>
+                <a:cs typeface="Calibri" pitchFamily="34" charset="-120"/>
+              </a:rPr>
+              <a:t>Which Major_category has the best median salary and employment rate?</a:t>
             </a:r>
             <a:endParaRPr lang="en-US" sz="1400" dirty="0"/>
           </a:p>
@@ -2483,7 +2548,7 @@
                 <a:ea typeface="Calibri" pitchFamily="34" charset="-122"/>
                 <a:cs typeface="Calibri" pitchFamily="34" charset="-120"/>
               </a:rPr>
-              <a:t>CORE EXCEL MOVES</a:t>
+              <a:t>FEATURE ENGINEERING</a:t>
             </a:r>
             <a:endParaRPr lang="en-US" sz="1200" dirty="0"/>
           </a:p>
@@ -2516,13 +2581,13 @@
             <a:r>
               <a:rPr lang="en-US" sz="2700" b="1" dirty="0">
                 <a:solidFill>
-                  <a:srgbClr val="1B3A34"/>
+                  <a:srgbClr val="1C3F60"/>
                 </a:solidFill>
                 <a:latin typeface="Georgia" pitchFamily="34" charset="0"/>
                 <a:ea typeface="Georgia" pitchFamily="34" charset="-122"/>
                 <a:cs typeface="Georgia" pitchFamily="34" charset="-120"/>
               </a:rPr>
-              <a:t>Every skill, in service of a question</a:t>
+              <a:t>A column that didn't exist</a:t>
             </a:r>
             <a:endParaRPr lang="en-US" sz="2700" dirty="0"/>
           </a:p>
@@ -2530,14 +2595,36 @@
       </p:sp>
       <p:sp>
         <p:nvSpPr>
-          <p:cNvPr id="4" name="Text 2"/>
-          <p:cNvSpPr/>
-          <p:nvPr/>
-        </p:nvSpPr>
-        <p:spPr>
-          <a:xfrm>
-            <a:off x="640080" y="2057400"/>
-            <a:ext cx="548640" cy="548640"/>
+          <p:cNvPr id="4" name="Shape 2"/>
+          <p:cNvSpPr/>
+          <p:nvPr/>
+        </p:nvSpPr>
+        <p:spPr>
+          <a:xfrm>
+            <a:off x="640080" y="2103120"/>
+            <a:ext cx="10881360" cy="1188720"/>
+          </a:xfrm>
+          <a:prstGeom prst="roundRect">
+            <a:avLst>
+              <a:gd name="adj" fmla="val 4615"/>
+            </a:avLst>
+          </a:prstGeom>
+          <a:solidFill>
+            <a:srgbClr val="1C3F60"/>
+          </a:solidFill>
+          <a:ln/>
+        </p:spPr>
+      </p:sp>
+      <p:sp>
+        <p:nvSpPr>
+          <p:cNvPr id="5" name="Text 3"/>
+          <p:cNvSpPr/>
+          <p:nvPr/>
+        </p:nvSpPr>
+        <p:spPr>
+          <a:xfrm>
+            <a:off x="1005840" y="2103120"/>
+            <a:ext cx="10149840" cy="1188720"/>
           </a:xfrm>
           <a:prstGeom prst="rect">
             <a:avLst/>
@@ -2549,333 +2636,60 @@
           <a:bodyPr wrap="square" rtlCol="0" anchor="ctr"/>
           <a:lstStyle/>
           <a:p>
-            <a:pPr indent="0" marL="0">
-              <a:buNone/>
-            </a:pPr>
-            <a:r>
-              <a:rPr lang="en-US" sz="2400" b="1" dirty="0">
-                <a:solidFill>
-                  <a:srgbClr val="D97E3F"/>
-                </a:solidFill>
-                <a:latin typeface="Georgia" pitchFamily="34" charset="0"/>
-                <a:ea typeface="Georgia" pitchFamily="34" charset="-122"/>
-                <a:cs typeface="Georgia" pitchFamily="34" charset="-120"/>
-              </a:rPr>
-              <a:t>1</a:t>
-            </a:r>
-            <a:endParaRPr lang="en-US" sz="2400" dirty="0"/>
-          </a:p>
-        </p:txBody>
-      </p:sp>
-      <p:sp>
-        <p:nvSpPr>
-          <p:cNvPr id="5" name="Text 3"/>
-          <p:cNvSpPr/>
-          <p:nvPr/>
-        </p:nvSpPr>
-        <p:spPr>
-          <a:xfrm>
-            <a:off x="1280160" y="2039112"/>
-            <a:ext cx="2743200" cy="1097280"/>
-          </a:xfrm>
-          <a:prstGeom prst="rect">
-            <a:avLst/>
-          </a:prstGeom>
-          <a:noFill/>
-          <a:ln/>
-        </p:spPr>
-        <p:txBody>
-          <a:bodyPr wrap="square" rtlCol="0" anchor="t"/>
-          <a:lstStyle/>
-          <a:p>
-            <a:pPr indent="0" marL="0">
+            <a:pPr algn="ctr" indent="0" marL="0">
               <a:buNone/>
             </a:pPr>
             <a:r>
               <a:rPr lang="en-US" sz="1600" b="1" dirty="0">
                 <a:solidFill>
-                  <a:srgbClr val="1B3A34"/>
+                  <a:srgbClr val="FFFFFF"/>
+                </a:solidFill>
+                <a:latin typeface="Courier New" pitchFamily="34" charset="0"/>
+                <a:ea typeface="Courier New" pitchFamily="34" charset="-122"/>
+                <a:cs typeface="Courier New" pitchFamily="34" charset="-120"/>
+              </a:rPr>
+              <a:t>Underemployment_rate = (Non_college_jobs + Low_wage_jobs) / Employed</a:t>
+            </a:r>
+            <a:endParaRPr lang="en-US" sz="1600" dirty="0"/>
+          </a:p>
+        </p:txBody>
+      </p:sp>
+      <p:sp>
+        <p:nvSpPr>
+          <p:cNvPr id="6" name="Text 4"/>
+          <p:cNvSpPr/>
+          <p:nvPr/>
+        </p:nvSpPr>
+        <p:spPr>
+          <a:xfrm>
+            <a:off x="640080" y="3657600"/>
+            <a:ext cx="9875520" cy="731520"/>
+          </a:xfrm>
+          <a:prstGeom prst="rect">
+            <a:avLst/>
+          </a:prstGeom>
+          <a:noFill/>
+          <a:ln/>
+        </p:spPr>
+        <p:txBody>
+          <a:bodyPr wrap="square" rtlCol="0" anchor="ctr"/>
+          <a:lstStyle/>
+          <a:p>
+            <a:pPr indent="0" marL="0">
+              <a:buNone/>
+            </a:pPr>
+            <a:r>
+              <a:rPr lang="en-US" sz="1600" dirty="0">
+                <a:solidFill>
+                  <a:srgbClr val="2A2A2A"/>
                 </a:solidFill>
                 <a:latin typeface="Calibri" pitchFamily="34" charset="0"/>
                 <a:ea typeface="Calibri" pitchFamily="34" charset="-122"/>
                 <a:cs typeface="Calibri" pitchFamily="34" charset="-120"/>
               </a:rPr>
-              <a:t>Sort &amp; filter</a:t>
+              <a:t>Most of an analyst's job is exactly this. Raw columns rarely answer the real question alone.</a:t>
             </a:r>
             <a:endParaRPr lang="en-US" sz="1600" dirty="0"/>
-          </a:p>
-        </p:txBody>
-      </p:sp>
-      <p:sp>
-        <p:nvSpPr>
-          <p:cNvPr id="6" name="Text 4"/>
-          <p:cNvSpPr/>
-          <p:nvPr/>
-        </p:nvSpPr>
-        <p:spPr>
-          <a:xfrm>
-            <a:off x="4206240" y="2039112"/>
-            <a:ext cx="7223760" cy="1097280"/>
-          </a:xfrm>
-          <a:prstGeom prst="rect">
-            <a:avLst/>
-          </a:prstGeom>
-          <a:noFill/>
-          <a:ln/>
-        </p:spPr>
-        <p:txBody>
-          <a:bodyPr wrap="square" rtlCol="0" anchor="t"/>
-          <a:lstStyle/>
-          <a:p>
-            <a:pPr indent="0" marL="0">
-              <a:buNone/>
-            </a:pPr>
-            <a:r>
-              <a:rPr lang="en-US" sz="1350" i="1" dirty="0">
-                <a:solidFill>
-                  <a:srgbClr val="2A2A2A"/>
-                </a:solidFill>
-                <a:latin typeface="Calibri" pitchFamily="34" charset="0"/>
-                <a:ea typeface="Calibri" pitchFamily="34" charset="-122"/>
-                <a:cs typeface="Calibri" pitchFamily="34" charset="-120"/>
-              </a:rPr>
-              <a:t>“Which majors have the highest unemployment rate — and do you still trust that ranking once you check Sample_size?”</a:t>
-            </a:r>
-            <a:endParaRPr lang="en-US" sz="1350" dirty="0"/>
-          </a:p>
-        </p:txBody>
-      </p:sp>
-      <p:sp>
-        <p:nvSpPr>
-          <p:cNvPr id="7" name="Text 5"/>
-          <p:cNvSpPr/>
-          <p:nvPr/>
-        </p:nvSpPr>
-        <p:spPr>
-          <a:xfrm>
-            <a:off x="640080" y="3291840"/>
-            <a:ext cx="548640" cy="548640"/>
-          </a:xfrm>
-          <a:prstGeom prst="rect">
-            <a:avLst/>
-          </a:prstGeom>
-          <a:noFill/>
-          <a:ln/>
-        </p:spPr>
-        <p:txBody>
-          <a:bodyPr wrap="square" rtlCol="0" anchor="ctr"/>
-          <a:lstStyle/>
-          <a:p>
-            <a:pPr indent="0" marL="0">
-              <a:buNone/>
-            </a:pPr>
-            <a:r>
-              <a:rPr lang="en-US" sz="2400" b="1" dirty="0">
-                <a:solidFill>
-                  <a:srgbClr val="D97E3F"/>
-                </a:solidFill>
-                <a:latin typeface="Georgia" pitchFamily="34" charset="0"/>
-                <a:ea typeface="Georgia" pitchFamily="34" charset="-122"/>
-                <a:cs typeface="Georgia" pitchFamily="34" charset="-120"/>
-              </a:rPr>
-              <a:t>2</a:t>
-            </a:r>
-            <a:endParaRPr lang="en-US" sz="2400" dirty="0"/>
-          </a:p>
-        </p:txBody>
-      </p:sp>
-      <p:sp>
-        <p:nvSpPr>
-          <p:cNvPr id="8" name="Text 6"/>
-          <p:cNvSpPr/>
-          <p:nvPr/>
-        </p:nvSpPr>
-        <p:spPr>
-          <a:xfrm>
-            <a:off x="1280160" y="3273552"/>
-            <a:ext cx="2743200" cy="1097280"/>
-          </a:xfrm>
-          <a:prstGeom prst="rect">
-            <a:avLst/>
-          </a:prstGeom>
-          <a:noFill/>
-          <a:ln/>
-        </p:spPr>
-        <p:txBody>
-          <a:bodyPr wrap="square" rtlCol="0" anchor="t"/>
-          <a:lstStyle/>
-          <a:p>
-            <a:pPr indent="0" marL="0">
-              <a:buNone/>
-            </a:pPr>
-            <a:r>
-              <a:rPr lang="en-US" sz="1600" b="1" dirty="0">
-                <a:solidFill>
-                  <a:srgbClr val="1B3A34"/>
-                </a:solidFill>
-                <a:latin typeface="Calibri" pitchFamily="34" charset="0"/>
-                <a:ea typeface="Calibri" pitchFamily="34" charset="-122"/>
-                <a:cs typeface="Calibri" pitchFamily="34" charset="-120"/>
-              </a:rPr>
-              <a:t>A calculated column</a:t>
-            </a:r>
-            <a:endParaRPr lang="en-US" sz="1600" dirty="0"/>
-          </a:p>
-        </p:txBody>
-      </p:sp>
-      <p:sp>
-        <p:nvSpPr>
-          <p:cNvPr id="9" name="Text 7"/>
-          <p:cNvSpPr/>
-          <p:nvPr/>
-        </p:nvSpPr>
-        <p:spPr>
-          <a:xfrm>
-            <a:off x="4206240" y="3273552"/>
-            <a:ext cx="7223760" cy="1097280"/>
-          </a:xfrm>
-          <a:prstGeom prst="rect">
-            <a:avLst/>
-          </a:prstGeom>
-          <a:noFill/>
-          <a:ln/>
-        </p:spPr>
-        <p:txBody>
-          <a:bodyPr wrap="square" rtlCol="0" anchor="t"/>
-          <a:lstStyle/>
-          <a:p>
-            <a:pPr indent="0" marL="0">
-              <a:buNone/>
-            </a:pPr>
-            <a:r>
-              <a:rPr lang="en-US" sz="1350" i="1" dirty="0">
-                <a:solidFill>
-                  <a:srgbClr val="2A2A2A"/>
-                </a:solidFill>
-                <a:latin typeface="Calibri" pitchFamily="34" charset="0"/>
-                <a:ea typeface="Calibri" pitchFamily="34" charset="-122"/>
-                <a:cs typeface="Calibri" pitchFamily="34" charset="-120"/>
-              </a:rPr>
-              <a:t>“How many graduates end up in a job outside their field?” — build Underemployment_rate from scratch.</a:t>
-            </a:r>
-            <a:endParaRPr lang="en-US" sz="1350" dirty="0"/>
-          </a:p>
-        </p:txBody>
-      </p:sp>
-      <p:sp>
-        <p:nvSpPr>
-          <p:cNvPr id="10" name="Text 8"/>
-          <p:cNvSpPr/>
-          <p:nvPr/>
-        </p:nvSpPr>
-        <p:spPr>
-          <a:xfrm>
-            <a:off x="640080" y="4526280"/>
-            <a:ext cx="548640" cy="548640"/>
-          </a:xfrm>
-          <a:prstGeom prst="rect">
-            <a:avLst/>
-          </a:prstGeom>
-          <a:noFill/>
-          <a:ln/>
-        </p:spPr>
-        <p:txBody>
-          <a:bodyPr wrap="square" rtlCol="0" anchor="ctr"/>
-          <a:lstStyle/>
-          <a:p>
-            <a:pPr indent="0" marL="0">
-              <a:buNone/>
-            </a:pPr>
-            <a:r>
-              <a:rPr lang="en-US" sz="2400" b="1" dirty="0">
-                <a:solidFill>
-                  <a:srgbClr val="D97E3F"/>
-                </a:solidFill>
-                <a:latin typeface="Georgia" pitchFamily="34" charset="0"/>
-                <a:ea typeface="Georgia" pitchFamily="34" charset="-122"/>
-                <a:cs typeface="Georgia" pitchFamily="34" charset="-120"/>
-              </a:rPr>
-              <a:t>3</a:t>
-            </a:r>
-            <a:endParaRPr lang="en-US" sz="2400" dirty="0"/>
-          </a:p>
-        </p:txBody>
-      </p:sp>
-      <p:sp>
-        <p:nvSpPr>
-          <p:cNvPr id="11" name="Text 9"/>
-          <p:cNvSpPr/>
-          <p:nvPr/>
-        </p:nvSpPr>
-        <p:spPr>
-          <a:xfrm>
-            <a:off x="1280160" y="4507992"/>
-            <a:ext cx="2743200" cy="1097280"/>
-          </a:xfrm>
-          <a:prstGeom prst="rect">
-            <a:avLst/>
-          </a:prstGeom>
-          <a:noFill/>
-          <a:ln/>
-        </p:spPr>
-        <p:txBody>
-          <a:bodyPr wrap="square" rtlCol="0" anchor="t"/>
-          <a:lstStyle/>
-          <a:p>
-            <a:pPr indent="0" marL="0">
-              <a:buNone/>
-            </a:pPr>
-            <a:r>
-              <a:rPr lang="en-US" sz="1600" b="1" dirty="0">
-                <a:solidFill>
-                  <a:srgbClr val="1B3A34"/>
-                </a:solidFill>
-                <a:latin typeface="Calibri" pitchFamily="34" charset="0"/>
-                <a:ea typeface="Calibri" pitchFamily="34" charset="-122"/>
-                <a:cs typeface="Calibri" pitchFamily="34" charset="-120"/>
-              </a:rPr>
-              <a:t>Pivot table</a:t>
-            </a:r>
-            <a:endParaRPr lang="en-US" sz="1600" dirty="0"/>
-          </a:p>
-        </p:txBody>
-      </p:sp>
-      <p:sp>
-        <p:nvSpPr>
-          <p:cNvPr id="12" name="Text 10"/>
-          <p:cNvSpPr/>
-          <p:nvPr/>
-        </p:nvSpPr>
-        <p:spPr>
-          <a:xfrm>
-            <a:off x="4206240" y="4507992"/>
-            <a:ext cx="7223760" cy="1097280"/>
-          </a:xfrm>
-          <a:prstGeom prst="rect">
-            <a:avLst/>
-          </a:prstGeom>
-          <a:noFill/>
-          <a:ln/>
-        </p:spPr>
-        <p:txBody>
-          <a:bodyPr wrap="square" rtlCol="0" anchor="t"/>
-          <a:lstStyle/>
-          <a:p>
-            <a:pPr indent="0" marL="0">
-              <a:buNone/>
-            </a:pPr>
-            <a:r>
-              <a:rPr lang="en-US" sz="1350" i="1" dirty="0">
-                <a:solidFill>
-                  <a:srgbClr val="2A2A2A"/>
-                </a:solidFill>
-                <a:latin typeface="Calibri" pitchFamily="34" charset="0"/>
-                <a:ea typeface="Calibri" pitchFamily="34" charset="-122"/>
-                <a:cs typeface="Calibri" pitchFamily="34" charset="-120"/>
-              </a:rPr>
-              <a:t>“Which Major_category has the best median salary and the best employment rate?”</a:t>
-            </a:r>
-            <a:endParaRPr lang="en-US" sz="1350" dirty="0"/>
           </a:p>
         </p:txBody>
       </p:sp>
@@ -2944,7 +2758,7 @@
                 <a:ea typeface="Calibri" pitchFamily="34" charset="-122"/>
                 <a:cs typeface="Calibri" pitchFamily="34" charset="-120"/>
               </a:rPr>
-              <a:t>FEATURE ENGINEERING</a:t>
+              <a:t>THE RELATIONSHIP WORTH ARGUING ABOUT</a:t>
             </a:r>
             <a:endParaRPr lang="en-US" sz="1200" dirty="0"/>
           </a:p>
@@ -2977,13 +2791,13 @@
             <a:r>
               <a:rPr lang="en-US" sz="2700" b="1" dirty="0">
                 <a:solidFill>
-                  <a:srgbClr val="1B3A34"/>
+                  <a:srgbClr val="1C3F60"/>
                 </a:solidFill>
                 <a:latin typeface="Georgia" pitchFamily="34" charset="0"/>
                 <a:ea typeface="Georgia" pitchFamily="34" charset="-122"/>
                 <a:cs typeface="Georgia" pitchFamily="34" charset="-120"/>
               </a:rPr>
-              <a:t>A column that didn't exist</a:t>
+              <a:t>ShareWomen vs. Median salary</a:t>
             </a:r>
             <a:endParaRPr lang="en-US" sz="2700" dirty="0"/>
           </a:p>
@@ -2991,36 +2805,14 @@
       </p:sp>
       <p:sp>
         <p:nvSpPr>
-          <p:cNvPr id="4" name="Shape 2"/>
-          <p:cNvSpPr/>
-          <p:nvPr/>
-        </p:nvSpPr>
-        <p:spPr>
-          <a:xfrm>
-            <a:off x="640080" y="2103120"/>
-            <a:ext cx="10881360" cy="1188720"/>
-          </a:xfrm>
-          <a:prstGeom prst="roundRect">
-            <a:avLst>
-              <a:gd name="adj" fmla="val 4615"/>
-            </a:avLst>
-          </a:prstGeom>
-          <a:solidFill>
-            <a:srgbClr val="1B3A34"/>
-          </a:solidFill>
-          <a:ln/>
-        </p:spPr>
-      </p:sp>
-      <p:sp>
-        <p:nvSpPr>
-          <p:cNvPr id="5" name="Text 3"/>
-          <p:cNvSpPr/>
-          <p:nvPr/>
-        </p:nvSpPr>
-        <p:spPr>
-          <a:xfrm>
-            <a:off x="1005840" y="2103120"/>
-            <a:ext cx="10149840" cy="1188720"/>
+          <p:cNvPr id="4" name="Text 2"/>
+          <p:cNvSpPr/>
+          <p:nvPr/>
+        </p:nvSpPr>
+        <p:spPr>
+          <a:xfrm>
+            <a:off x="640080" y="1874520"/>
+            <a:ext cx="10058400" cy="548640"/>
           </a:xfrm>
           <a:prstGeom prst="rect">
             <a:avLst/>
@@ -3032,23 +2824,45 @@
           <a:bodyPr wrap="square" rtlCol="0" anchor="ctr"/>
           <a:lstStyle/>
           <a:p>
-            <a:pPr algn="ctr" indent="0" marL="0">
-              <a:buNone/>
-            </a:pPr>
-            <a:r>
-              <a:rPr lang="en-US" sz="1600" b="1" dirty="0">
-                <a:solidFill>
-                  <a:srgbClr val="FFFFFF"/>
+            <a:pPr indent="0" marL="0">
+              <a:buNone/>
+            </a:pPr>
+            <a:r>
+              <a:rPr lang="en-US" sz="2000" b="1" dirty="0">
+                <a:solidFill>
+                  <a:srgbClr val="D97E3F"/>
                 </a:solidFill>
                 <a:latin typeface="Courier New" pitchFamily="34" charset="0"/>
                 <a:ea typeface="Courier New" pitchFamily="34" charset="-122"/>
                 <a:cs typeface="Courier New" pitchFamily="34" charset="-120"/>
               </a:rPr>
-              <a:t>Underemployment_rate = (Non_college_jobs + Low_wage_jobs) / Employed</a:t>
-            </a:r>
-            <a:endParaRPr lang="en-US" sz="1600" dirty="0"/>
-          </a:p>
-        </p:txBody>
+              <a:t>=CORREL(ShareWomen, Median)  ≈  −0.62</a:t>
+            </a:r>
+            <a:endParaRPr lang="en-US" sz="2000" dirty="0"/>
+          </a:p>
+        </p:txBody>
+      </p:sp>
+      <p:sp>
+        <p:nvSpPr>
+          <p:cNvPr id="5" name="Shape 3"/>
+          <p:cNvSpPr/>
+          <p:nvPr/>
+        </p:nvSpPr>
+        <p:spPr>
+          <a:xfrm>
+            <a:off x="640080" y="2606040"/>
+            <a:ext cx="10881360" cy="2103120"/>
+          </a:xfrm>
+          <a:prstGeom prst="roundRect">
+            <a:avLst>
+              <a:gd name="adj" fmla="val 2609"/>
+            </a:avLst>
+          </a:prstGeom>
+          <a:solidFill>
+            <a:srgbClr val="F4F1EC"/>
+          </a:solidFill>
+          <a:ln/>
+        </p:spPr>
       </p:sp>
       <p:sp>
         <p:nvSpPr>
@@ -3058,8 +2872,8 @@
         </p:nvSpPr>
         <p:spPr>
           <a:xfrm>
-            <a:off x="640080" y="3657600"/>
-            <a:ext cx="10058400" cy="1188720"/>
+            <a:off x="1005840" y="2834640"/>
+            <a:ext cx="10149840" cy="548640"/>
           </a:xfrm>
           <a:prstGeom prst="rect">
             <a:avLst/>
@@ -3075,17 +2889,56 @@
               <a:buNone/>
             </a:pPr>
             <a:r>
-              <a:rPr lang="en-US" sz="1600" i="1" dirty="0">
-                <a:solidFill>
-                  <a:srgbClr val="2A2A2A"/>
+              <a:rPr lang="en-US" sz="1600" b="1" dirty="0">
+                <a:solidFill>
+                  <a:srgbClr val="1C3F60"/>
                 </a:solidFill>
                 <a:latin typeface="Calibri" pitchFamily="34" charset="0"/>
                 <a:ea typeface="Calibri" pitchFamily="34" charset="-122"/>
                 <a:cs typeface="Calibri" pitchFamily="34" charset="-120"/>
               </a:rPr>
-              <a:t>“You just built a column that didn't exist. That's most of what an analyst actually does — raw columns rarely answer the real question by themselves.”</a:t>
+              <a:t>Name three explanations for this pattern that aren't just “discrimination” or “coincidence.”</a:t>
             </a:r>
             <a:endParaRPr lang="en-US" sz="1600" dirty="0"/>
+          </a:p>
+        </p:txBody>
+      </p:sp>
+      <p:sp>
+        <p:nvSpPr>
+          <p:cNvPr id="7" name="Text 5"/>
+          <p:cNvSpPr/>
+          <p:nvPr/>
+        </p:nvSpPr>
+        <p:spPr>
+          <a:xfrm>
+            <a:off x="1005840" y="3429000"/>
+            <a:ext cx="10149840" cy="914400"/>
+          </a:xfrm>
+          <a:prstGeom prst="rect">
+            <a:avLst/>
+          </a:prstGeom>
+          <a:noFill/>
+          <a:ln/>
+        </p:spPr>
+        <p:txBody>
+          <a:bodyPr wrap="square" rtlCol="0" anchor="ctr"/>
+          <a:lstStyle/>
+          <a:p>
+            <a:pPr indent="0" marL="0">
+              <a:buNone/>
+            </a:pPr>
+            <a:r>
+              <a:rPr lang="en-US" sz="1350" dirty="0">
+                <a:solidFill>
+                  <a:srgbClr val="6B6B6B"/>
+                </a:solidFill>
+                <a:latin typeface="Calibri" pitchFamily="34" charset="0"/>
+                <a:ea typeface="Calibri" pitchFamily="34" charset="-122"/>
+                <a:cs typeface="Calibri" pitchFamily="34" charset="-120"/>
+              </a:rPr>
+              <a:t>The goal isn't a conclusion. It's the habit of asking what else could explain a pattern before repeating a correlation as a cause.</a:t>
+            </a:r>
+            <a:endParaRPr lang="en-US" sz="1350" dirty="0"/>
           </a:p>
         </p:txBody>
       </p:sp>
@@ -3100,6 +2953,231 @@
 <file path=ppt/slides/slide6.xml><?xml version="1.0" encoding="utf-8"?>
 <p:sld xmlns:a="http://schemas.openxmlformats.org/drawingml/2006/main" xmlns:r="http://schemas.openxmlformats.org/officeDocument/2006/relationships" xmlns:p="http://schemas.openxmlformats.org/presentationml/2006/main">
   <p:cSld name="Slide 6">
+    <p:bg>
+      <p:bgPr>
+        <a:solidFill>
+          <a:srgbClr val="1C3F60"/>
+        </a:solidFill>
+      </p:bgPr>
+    </p:bg>
+    <p:spTree>
+      <p:nvGrpSpPr>
+        <p:cNvPr id="1" name=""/>
+        <p:cNvGrpSpPr/>
+        <p:nvPr/>
+      </p:nvGrpSpPr>
+      <p:grpSpPr>
+        <a:xfrm>
+          <a:off x="0" y="0"/>
+          <a:ext cx="0" cy="0"/>
+          <a:chOff x="0" y="0"/>
+          <a:chExt cx="0" cy="0"/>
+        </a:xfrm>
+      </p:grpSpPr>
+      <p:sp>
+        <p:nvSpPr>
+          <p:cNvPr id="2" name="Text 0"/>
+          <p:cNvSpPr/>
+          <p:nvPr/>
+        </p:nvSpPr>
+        <p:spPr>
+          <a:xfrm>
+            <a:off x="640080" y="640080"/>
+            <a:ext cx="8229600" cy="365760"/>
+          </a:xfrm>
+          <a:prstGeom prst="rect">
+            <a:avLst/>
+          </a:prstGeom>
+          <a:noFill/>
+          <a:ln/>
+        </p:spPr>
+        <p:txBody>
+          <a:bodyPr wrap="square" rtlCol="0" anchor="ctr"/>
+          <a:lstStyle/>
+          <a:p>
+            <a:pPr indent="0" marL="0">
+              <a:buNone/>
+            </a:pPr>
+            <a:r>
+              <a:rPr lang="en-US" sz="1300" b="1" spc="200" kern="0" dirty="0">
+                <a:solidFill>
+                  <a:srgbClr val="D97E3F"/>
+                </a:solidFill>
+                <a:latin typeface="Calibri" pitchFamily="34" charset="0"/>
+                <a:ea typeface="Calibri" pitchFamily="34" charset="-122"/>
+                <a:cs typeface="Calibri" pitchFamily="34" charset="-120"/>
+              </a:rPr>
+              <a:t>OPEN EXPLORATION — 25 MIN</a:t>
+            </a:r>
+            <a:endParaRPr lang="en-US" sz="1300" dirty="0"/>
+          </a:p>
+        </p:txBody>
+      </p:sp>
+      <p:sp>
+        <p:nvSpPr>
+          <p:cNvPr id="3" name="Text 1"/>
+          <p:cNvSpPr/>
+          <p:nvPr/>
+        </p:nvSpPr>
+        <p:spPr>
+          <a:xfrm>
+            <a:off x="640080" y="1051560"/>
+            <a:ext cx="10332720" cy="1737360"/>
+          </a:xfrm>
+          <a:prstGeom prst="rect">
+            <a:avLst/>
+          </a:prstGeom>
+          <a:noFill/>
+          <a:ln/>
+        </p:spPr>
+        <p:txBody>
+          <a:bodyPr wrap="square" rtlCol="0" anchor="ctr"/>
+          <a:lstStyle/>
+          <a:p>
+            <a:pPr indent="0" marL="0">
+              <a:buNone/>
+            </a:pPr>
+            <a:r>
+              <a:rPr lang="en-US" sz="3000" b="1" dirty="0">
+                <a:solidFill>
+                  <a:srgbClr val="FFFFFF"/>
+                </a:solidFill>
+                <a:latin typeface="Georgia" pitchFamily="34" charset="0"/>
+                <a:ea typeface="Georgia" pitchFamily="34" charset="-122"/>
+                <a:cs typeface="Georgia" pitchFamily="34" charset="-120"/>
+              </a:rPr>
+              <a:t>Find one relationship</a:t>
+            </a:r>
+            <a:endParaRPr lang="en-US" sz="3000" dirty="0"/>
+          </a:p>
+          <a:p>
+            <a:pPr indent="0" marL="0">
+              <a:buNone/>
+            </a:pPr>
+            <a:r>
+              <a:rPr lang="en-US" sz="3000" b="1" dirty="0">
+                <a:solidFill>
+                  <a:srgbClr val="FFFFFF"/>
+                </a:solidFill>
+                <a:latin typeface="Georgia" pitchFamily="34" charset="0"/>
+                <a:ea typeface="Georgia" pitchFamily="34" charset="-122"/>
+                <a:cs typeface="Georgia" pitchFamily="34" charset="-120"/>
+              </a:rPr>
+              <a:t>you didn't expect</a:t>
+            </a:r>
+            <a:endParaRPr lang="en-US" sz="3000" dirty="0"/>
+          </a:p>
+        </p:txBody>
+      </p:sp>
+      <p:sp>
+        <p:nvSpPr>
+          <p:cNvPr id="4" name="Text 2"/>
+          <p:cNvSpPr/>
+          <p:nvPr/>
+        </p:nvSpPr>
+        <p:spPr>
+          <a:xfrm>
+            <a:off x="640080" y="2880360"/>
+            <a:ext cx="10058400" cy="548640"/>
+          </a:xfrm>
+          <a:prstGeom prst="rect">
+            <a:avLst/>
+          </a:prstGeom>
+          <a:noFill/>
+          <a:ln/>
+        </p:spPr>
+        <p:txBody>
+          <a:bodyPr wrap="square" rtlCol="0" anchor="ctr"/>
+          <a:lstStyle/>
+          <a:p>
+            <a:pPr indent="0" marL="0">
+              <a:buNone/>
+            </a:pPr>
+            <a:r>
+              <a:rPr lang="en-US" sz="1700" dirty="0">
+                <a:solidFill>
+                  <a:srgbClr val="D6E2EA"/>
+                </a:solidFill>
+                <a:latin typeface="Calibri" pitchFamily="34" charset="0"/>
+                <a:ea typeface="Calibri" pitchFamily="34" charset="-122"/>
+                <a:cs typeface="Calibri" pitchFamily="34" charset="-120"/>
+              </a:rPr>
+              <a:t>Using at least one column you built yourself. No approved question list.</a:t>
+            </a:r>
+            <a:endParaRPr lang="en-US" sz="1700" dirty="0"/>
+          </a:p>
+        </p:txBody>
+      </p:sp>
+      <p:sp>
+        <p:nvSpPr>
+          <p:cNvPr id="5" name="Shape 3"/>
+          <p:cNvSpPr/>
+          <p:nvPr/>
+        </p:nvSpPr>
+        <p:spPr>
+          <a:xfrm>
+            <a:off x="640080" y="3657600"/>
+            <a:ext cx="10881360" cy="18288"/>
+          </a:xfrm>
+          <a:prstGeom prst="rect">
+            <a:avLst/>
+          </a:prstGeom>
+          <a:solidFill>
+            <a:srgbClr val="5B8A82"/>
+          </a:solidFill>
+          <a:ln/>
+        </p:spPr>
+      </p:sp>
+      <p:sp>
+        <p:nvSpPr>
+          <p:cNvPr id="6" name="Text 4"/>
+          <p:cNvSpPr/>
+          <p:nvPr/>
+        </p:nvSpPr>
+        <p:spPr>
+          <a:xfrm>
+            <a:off x="640080" y="3931920"/>
+            <a:ext cx="10058400" cy="457200"/>
+          </a:xfrm>
+          <a:prstGeom prst="rect">
+            <a:avLst/>
+          </a:prstGeom>
+          <a:noFill/>
+          <a:ln/>
+        </p:spPr>
+        <p:txBody>
+          <a:bodyPr wrap="square" rtlCol="0" anchor="ctr"/>
+          <a:lstStyle/>
+          <a:p>
+            <a:pPr indent="0" marL="0">
+              <a:buNone/>
+            </a:pPr>
+            <a:r>
+              <a:rPr lang="en-US" sz="1400" dirty="0">
+                <a:solidFill>
+                  <a:srgbClr val="D6E2EA"/>
+                </a:solidFill>
+                <a:latin typeface="Calibri" pitchFamily="34" charset="0"/>
+                <a:ea typeface="Calibri" pitchFamily="34" charset="-122"/>
+                <a:cs typeface="Calibri" pitchFamily="34" charset="-120"/>
+              </a:rPr>
+              <a:t>Stuck? docs/asking-better-analytical-questions.md   ·   Finished early? Find a second, harder one.</a:t>
+            </a:r>
+            <a:endParaRPr lang="en-US" sz="1400" dirty="0"/>
+          </a:p>
+        </p:txBody>
+      </p:sp>
+    </p:spTree>
+  </p:cSld>
+  <p:clrMapOvr>
+    <a:masterClrMapping/>
+  </p:clrMapOvr>
+</p:sld>
+</file>
+
+<file path=ppt/slides/slide7.xml><?xml version="1.0" encoding="utf-8"?>
+<p:sld xmlns:a="http://schemas.openxmlformats.org/drawingml/2006/main" xmlns:r="http://schemas.openxmlformats.org/officeDocument/2006/relationships" xmlns:p="http://schemas.openxmlformats.org/presentationml/2006/main">
+  <p:cSld name="Slide 7">
     <p:bg>
       <p:bgPr>
         <a:solidFill>
@@ -3154,7 +3232,7 @@
                 <a:ea typeface="Calibri" pitchFamily="34" charset="-122"/>
                 <a:cs typeface="Calibri" pitchFamily="34" charset="-120"/>
               </a:rPr>
-              <a:t>THE RELATIONSHIP WORTH ARGUING ABOUT</a:t>
+              <a:t>NEXT WEEK</a:t>
             </a:r>
             <a:endParaRPr lang="en-US" sz="1200" dirty="0"/>
           </a:p>
@@ -3187,13 +3265,13 @@
             <a:r>
               <a:rPr lang="en-US" sz="2700" b="1" dirty="0">
                 <a:solidFill>
-                  <a:srgbClr val="1B3A34"/>
+                  <a:srgbClr val="1C3F60"/>
                 </a:solidFill>
                 <a:latin typeface="Georgia" pitchFamily="34" charset="0"/>
                 <a:ea typeface="Georgia" pitchFamily="34" charset="-122"/>
                 <a:cs typeface="Georgia" pitchFamily="34" charset="-120"/>
               </a:rPr>
-              <a:t>ShareWomen vs. Median salary</a:t>
+              <a:t>From spreadsheet to dashboard</a:t>
             </a:r>
             <a:endParaRPr lang="en-US" sz="2700" dirty="0"/>
           </a:p>
@@ -3207,8 +3285,8 @@
         </p:nvSpPr>
         <p:spPr>
           <a:xfrm>
-            <a:off x="640080" y="1965960"/>
-            <a:ext cx="10058400" cy="548640"/>
+            <a:off x="640080" y="2103120"/>
+            <a:ext cx="10058400" cy="822960"/>
           </a:xfrm>
           <a:prstGeom prst="rect">
             <a:avLst/>
@@ -3224,17 +3302,17 @@
               <a:buNone/>
             </a:pPr>
             <a:r>
-              <a:rPr lang="en-US" sz="2000" b="1" dirty="0">
-                <a:solidFill>
-                  <a:srgbClr val="D97E3F"/>
-                </a:solidFill>
-                <a:latin typeface="Courier New" pitchFamily="34" charset="0"/>
-                <a:ea typeface="Courier New" pitchFamily="34" charset="-122"/>
-                <a:cs typeface="Courier New" pitchFamily="34" charset="-120"/>
-              </a:rPr>
-              <a:t>=CORREL(ShareWomen, Median)  ≈  −0.62</a:t>
-            </a:r>
-            <a:endParaRPr lang="en-US" sz="2000" dirty="0"/>
+              <a:rPr lang="en-US" sz="2600" b="1" dirty="0">
+                <a:solidFill>
+                  <a:srgbClr val="1C3F60"/>
+                </a:solidFill>
+                <a:latin typeface="Georgia" pitchFamily="34" charset="0"/>
+                <a:ea typeface="Georgia" pitchFamily="34" charset="-122"/>
+                <a:cs typeface="Georgia" pitchFamily="34" charset="-120"/>
+              </a:rPr>
+              <a:t>Same dataset, Tableau this time.</a:t>
+            </a:r>
+            <a:endParaRPr lang="en-US" sz="2600" dirty="0"/>
           </a:p>
         </p:txBody>
       </p:sp>
@@ -3246,8 +3324,8 @@
         </p:nvSpPr>
         <p:spPr>
           <a:xfrm>
-            <a:off x="640080" y="2606040"/>
-            <a:ext cx="10058400" cy="548640"/>
+            <a:off x="640080" y="3108960"/>
+            <a:ext cx="9875520" cy="914400"/>
           </a:xfrm>
           <a:prstGeom prst="rect">
             <a:avLst/>
@@ -3271,710 +3349,9 @@
                 <a:ea typeface="Calibri" pitchFamily="34" charset="-122"/>
                 <a:cs typeface="Calibri" pitchFamily="34" charset="-120"/>
               </a:rPr>
-              <a:t>A real, meaningfully negative correlation. Sit with it for a minute before explaining it away.</a:t>
+              <a:t>A finding someone has to take your word for isn't a finding yet. Bring whatever you built today — your column carries forward.</a:t>
             </a:r>
             <a:endParaRPr lang="en-US" sz="1500" dirty="0"/>
-          </a:p>
-        </p:txBody>
-      </p:sp>
-      <p:sp>
-        <p:nvSpPr>
-          <p:cNvPr id="6" name="Shape 4"/>
-          <p:cNvSpPr/>
-          <p:nvPr/>
-        </p:nvSpPr>
-        <p:spPr>
-          <a:xfrm>
-            <a:off x="640080" y="3337560"/>
-            <a:ext cx="10881360" cy="2011680"/>
-          </a:xfrm>
-          <a:prstGeom prst="roundRect">
-            <a:avLst>
-              <a:gd name="adj" fmla="val 2727"/>
-            </a:avLst>
-          </a:prstGeom>
-          <a:solidFill>
-            <a:srgbClr val="F4F1EC"/>
-          </a:solidFill>
-          <a:ln/>
-        </p:spPr>
-      </p:sp>
-      <p:sp>
-        <p:nvSpPr>
-          <p:cNvPr id="7" name="Text 5"/>
-          <p:cNvSpPr/>
-          <p:nvPr/>
-        </p:nvSpPr>
-        <p:spPr>
-          <a:xfrm>
-            <a:off x="1005840" y="3566160"/>
-            <a:ext cx="10149840" cy="548640"/>
-          </a:xfrm>
-          <a:prstGeom prst="rect">
-            <a:avLst/>
-          </a:prstGeom>
-          <a:noFill/>
-          <a:ln/>
-        </p:spPr>
-        <p:txBody>
-          <a:bodyPr wrap="square" rtlCol="0" anchor="ctr"/>
-          <a:lstStyle/>
-          <a:p>
-            <a:pPr indent="0" marL="0">
-              <a:buNone/>
-            </a:pPr>
-            <a:r>
-              <a:rPr lang="en-US" sz="1600" b="1" dirty="0">
-                <a:solidFill>
-                  <a:srgbClr val="1B3A34"/>
-                </a:solidFill>
-                <a:latin typeface="Calibri" pitchFamily="34" charset="0"/>
-                <a:ea typeface="Calibri" pitchFamily="34" charset="-122"/>
-                <a:cs typeface="Calibri" pitchFamily="34" charset="-120"/>
-              </a:rPr>
-              <a:t>Name three different explanations for this pattern that don't all reduce to “discrimination” or “coincidence.”</a:t>
-            </a:r>
-            <a:endParaRPr lang="en-US" sz="1600" dirty="0"/>
-          </a:p>
-        </p:txBody>
-      </p:sp>
-      <p:sp>
-        <p:nvSpPr>
-          <p:cNvPr id="8" name="Text 6"/>
-          <p:cNvSpPr/>
-          <p:nvPr/>
-        </p:nvSpPr>
-        <p:spPr>
-          <a:xfrm>
-            <a:off x="1005840" y="4206240"/>
-            <a:ext cx="10149840" cy="914400"/>
-          </a:xfrm>
-          <a:prstGeom prst="rect">
-            <a:avLst/>
-          </a:prstGeom>
-          <a:noFill/>
-          <a:ln/>
-        </p:spPr>
-        <p:txBody>
-          <a:bodyPr wrap="square" rtlCol="0" anchor="ctr"/>
-          <a:lstStyle/>
-          <a:p>
-            <a:pPr indent="0" marL="0">
-              <a:buNone/>
-            </a:pPr>
-            <a:r>
-              <a:rPr lang="en-US" sz="1350" i="1" dirty="0">
-                <a:solidFill>
-                  <a:srgbClr val="6B6B6B"/>
-                </a:solidFill>
-                <a:latin typeface="Calibri" pitchFamily="34" charset="0"/>
-                <a:ea typeface="Calibri" pitchFamily="34" charset="-122"/>
-                <a:cs typeface="Calibri" pitchFamily="34" charset="-120"/>
-              </a:rPr>
-              <a:t>The goal isn't a conclusion — it's the instinct to ask “what else could explain this” before repeating a correlation as if it were a cause.</a:t>
-            </a:r>
-            <a:endParaRPr lang="en-US" sz="1350" dirty="0"/>
-          </a:p>
-        </p:txBody>
-      </p:sp>
-    </p:spTree>
-  </p:cSld>
-  <p:clrMapOvr>
-    <a:masterClrMapping/>
-  </p:clrMapOvr>
-</p:sld>
-</file>
-
-<file path=ppt/slides/slide7.xml><?xml version="1.0" encoding="utf-8"?>
-<p:sld xmlns:a="http://schemas.openxmlformats.org/drawingml/2006/main" xmlns:r="http://schemas.openxmlformats.org/officeDocument/2006/relationships" xmlns:p="http://schemas.openxmlformats.org/presentationml/2006/main">
-  <p:cSld name="Slide 7">
-    <p:bg>
-      <p:bgPr>
-        <a:solidFill>
-          <a:srgbClr val="1B3A34"/>
-        </a:solidFill>
-      </p:bgPr>
-    </p:bg>
-    <p:spTree>
-      <p:nvGrpSpPr>
-        <p:cNvPr id="1" name=""/>
-        <p:cNvGrpSpPr/>
-        <p:nvPr/>
-      </p:nvGrpSpPr>
-      <p:grpSpPr>
-        <a:xfrm>
-          <a:off x="0" y="0"/>
-          <a:ext cx="0" cy="0"/>
-          <a:chOff x="0" y="0"/>
-          <a:chExt cx="0" cy="0"/>
-        </a:xfrm>
-      </p:grpSpPr>
-      <p:sp>
-        <p:nvSpPr>
-          <p:cNvPr id="2" name="Text 0"/>
-          <p:cNvSpPr/>
-          <p:nvPr/>
-        </p:nvSpPr>
-        <p:spPr>
-          <a:xfrm>
-            <a:off x="640080" y="640080"/>
-            <a:ext cx="8229600" cy="365760"/>
-          </a:xfrm>
-          <a:prstGeom prst="rect">
-            <a:avLst/>
-          </a:prstGeom>
-          <a:noFill/>
-          <a:ln/>
-        </p:spPr>
-        <p:txBody>
-          <a:bodyPr wrap="square" rtlCol="0" anchor="ctr"/>
-          <a:lstStyle/>
-          <a:p>
-            <a:pPr indent="0" marL="0">
-              <a:buNone/>
-            </a:pPr>
-            <a:r>
-              <a:rPr lang="en-US" sz="1300" b="1" spc="200" kern="0" dirty="0">
-                <a:solidFill>
-                  <a:srgbClr val="D97E3F"/>
-                </a:solidFill>
-                <a:latin typeface="Calibri" pitchFamily="34" charset="0"/>
-                <a:ea typeface="Calibri" pitchFamily="34" charset="-122"/>
-                <a:cs typeface="Calibri" pitchFamily="34" charset="-120"/>
-              </a:rPr>
-              <a:t>OPEN EXPLORATION — 25 MIN</a:t>
-            </a:r>
-            <a:endParaRPr lang="en-US" sz="1300" dirty="0"/>
-          </a:p>
-        </p:txBody>
-      </p:sp>
-      <p:sp>
-        <p:nvSpPr>
-          <p:cNvPr id="3" name="Text 1"/>
-          <p:cNvSpPr/>
-          <p:nvPr/>
-        </p:nvSpPr>
-        <p:spPr>
-          <a:xfrm>
-            <a:off x="640080" y="1051560"/>
-            <a:ext cx="10332720" cy="1188720"/>
-          </a:xfrm>
-          <a:prstGeom prst="rect">
-            <a:avLst/>
-          </a:prstGeom>
-          <a:noFill/>
-          <a:ln/>
-        </p:spPr>
-        <p:txBody>
-          <a:bodyPr wrap="square" rtlCol="0" anchor="ctr"/>
-          <a:lstStyle/>
-          <a:p>
-            <a:pPr indent="0" marL="0">
-              <a:buNone/>
-            </a:pPr>
-            <a:r>
-              <a:rPr lang="en-US" sz="3000" b="1" dirty="0">
-                <a:solidFill>
-                  <a:srgbClr val="FFFFFF"/>
-                </a:solidFill>
-                <a:latin typeface="Georgia" pitchFamily="34" charset="0"/>
-                <a:ea typeface="Georgia" pitchFamily="34" charset="-122"/>
-                <a:cs typeface="Georgia" pitchFamily="34" charset="-120"/>
-              </a:rPr>
-              <a:t>Find one relationship you didn't expect</a:t>
-            </a:r>
-            <a:endParaRPr lang="en-US" sz="3000" dirty="0"/>
-          </a:p>
-        </p:txBody>
-      </p:sp>
-      <p:sp>
-        <p:nvSpPr>
-          <p:cNvPr id="4" name="Text 2"/>
-          <p:cNvSpPr/>
-          <p:nvPr/>
-        </p:nvSpPr>
-        <p:spPr>
-          <a:xfrm>
-            <a:off x="640080" y="2103120"/>
-            <a:ext cx="10058400" cy="548640"/>
-          </a:xfrm>
-          <a:prstGeom prst="rect">
-            <a:avLst/>
-          </a:prstGeom>
-          <a:noFill/>
-          <a:ln/>
-        </p:spPr>
-        <p:txBody>
-          <a:bodyPr wrap="square" rtlCol="0" anchor="ctr"/>
-          <a:lstStyle/>
-          <a:p>
-            <a:pPr indent="0" marL="0">
-              <a:buNone/>
-            </a:pPr>
-            <a:r>
-              <a:rPr lang="en-US" sz="1800" i="1" dirty="0">
-                <a:solidFill>
-                  <a:srgbClr val="D8E4E0"/>
-                </a:solidFill>
-                <a:latin typeface="Calibri" pitchFamily="34" charset="0"/>
-                <a:ea typeface="Calibri" pitchFamily="34" charset="-122"/>
-                <a:cs typeface="Calibri" pitchFamily="34" charset="-120"/>
-              </a:rPr>
-              <a:t>...using at least one column you had to build yourself.</a:t>
-            </a:r>
-            <a:endParaRPr lang="en-US" sz="1800" dirty="0"/>
-          </a:p>
-        </p:txBody>
-      </p:sp>
-      <p:sp>
-        <p:nvSpPr>
-          <p:cNvPr id="5" name="Text 3"/>
-          <p:cNvSpPr/>
-          <p:nvPr/>
-        </p:nvSpPr>
-        <p:spPr>
-          <a:xfrm>
-            <a:off x="640080" y="3291840"/>
-            <a:ext cx="274320" cy="457200"/>
-          </a:xfrm>
-          <a:prstGeom prst="rect">
-            <a:avLst/>
-          </a:prstGeom>
-          <a:noFill/>
-          <a:ln/>
-        </p:spPr>
-        <p:txBody>
-          <a:bodyPr wrap="square" rtlCol="0" anchor="ctr"/>
-          <a:lstStyle/>
-          <a:p>
-            <a:pPr indent="0" marL="0">
-              <a:buNone/>
-            </a:pPr>
-            <a:r>
-              <a:rPr lang="en-US" sz="1600" b="1" dirty="0">
-                <a:solidFill>
-                  <a:srgbClr val="D97E3F"/>
-                </a:solidFill>
-              </a:rPr>
-              <a:t>•</a:t>
-            </a:r>
-            <a:endParaRPr lang="en-US" sz="1600" dirty="0"/>
-          </a:p>
-        </p:txBody>
-      </p:sp>
-      <p:sp>
-        <p:nvSpPr>
-          <p:cNvPr id="6" name="Text 4"/>
-          <p:cNvSpPr/>
-          <p:nvPr/>
-        </p:nvSpPr>
-        <p:spPr>
-          <a:xfrm>
-            <a:off x="960120" y="3291840"/>
-            <a:ext cx="9601200" cy="457200"/>
-          </a:xfrm>
-          <a:prstGeom prst="rect">
-            <a:avLst/>
-          </a:prstGeom>
-          <a:noFill/>
-          <a:ln/>
-        </p:spPr>
-        <p:txBody>
-          <a:bodyPr wrap="square" rtlCol="0" anchor="ctr"/>
-          <a:lstStyle/>
-          <a:p>
-            <a:pPr indent="0" marL="0">
-              <a:buNone/>
-            </a:pPr>
-            <a:r>
-              <a:rPr lang="en-US" sz="1500" dirty="0">
-                <a:solidFill>
-                  <a:srgbClr val="E8E8E8"/>
-                </a:solidFill>
-                <a:latin typeface="Calibri" pitchFamily="34" charset="0"/>
-                <a:ea typeface="Calibri" pitchFamily="34" charset="-122"/>
-                <a:cs typeface="Calibri" pitchFamily="34" charset="-120"/>
-              </a:rPr>
-              <a:t>No approved question list — that's the point.</a:t>
-            </a:r>
-            <a:endParaRPr lang="en-US" sz="1500" dirty="0"/>
-          </a:p>
-        </p:txBody>
-      </p:sp>
-      <p:sp>
-        <p:nvSpPr>
-          <p:cNvPr id="7" name="Text 5"/>
-          <p:cNvSpPr/>
-          <p:nvPr/>
-        </p:nvSpPr>
-        <p:spPr>
-          <a:xfrm>
-            <a:off x="640080" y="3840480"/>
-            <a:ext cx="274320" cy="457200"/>
-          </a:xfrm>
-          <a:prstGeom prst="rect">
-            <a:avLst/>
-          </a:prstGeom>
-          <a:noFill/>
-          <a:ln/>
-        </p:spPr>
-        <p:txBody>
-          <a:bodyPr wrap="square" rtlCol="0" anchor="ctr"/>
-          <a:lstStyle/>
-          <a:p>
-            <a:pPr indent="0" marL="0">
-              <a:buNone/>
-            </a:pPr>
-            <a:r>
-              <a:rPr lang="en-US" sz="1600" b="1" dirty="0">
-                <a:solidFill>
-                  <a:srgbClr val="D97E3F"/>
-                </a:solidFill>
-              </a:rPr>
-              <a:t>•</a:t>
-            </a:r>
-            <a:endParaRPr lang="en-US" sz="1600" dirty="0"/>
-          </a:p>
-        </p:txBody>
-      </p:sp>
-      <p:sp>
-        <p:nvSpPr>
-          <p:cNvPr id="8" name="Text 6"/>
-          <p:cNvSpPr/>
-          <p:nvPr/>
-        </p:nvSpPr>
-        <p:spPr>
-          <a:xfrm>
-            <a:off x="960120" y="3840480"/>
-            <a:ext cx="9601200" cy="457200"/>
-          </a:xfrm>
-          <a:prstGeom prst="rect">
-            <a:avLst/>
-          </a:prstGeom>
-          <a:noFill/>
-          <a:ln/>
-        </p:spPr>
-        <p:txBody>
-          <a:bodyPr wrap="square" rtlCol="0" anchor="ctr"/>
-          <a:lstStyle/>
-          <a:p>
-            <a:pPr indent="0" marL="0">
-              <a:buNone/>
-            </a:pPr>
-            <a:r>
-              <a:rPr lang="en-US" sz="1500" dirty="0">
-                <a:solidFill>
-                  <a:srgbClr val="E8E8E8"/>
-                </a:solidFill>
-                <a:latin typeface="Calibri" pitchFamily="34" charset="0"/>
-                <a:ea typeface="Calibri" pitchFamily="34" charset="-122"/>
-                <a:cs typeface="Calibri" pitchFamily="34" charset="-120"/>
-              </a:rPr>
-              <a:t>Stuck? → docs/asking-better-analytical-questions.md</a:t>
-            </a:r>
-            <a:endParaRPr lang="en-US" sz="1500" dirty="0"/>
-          </a:p>
-        </p:txBody>
-      </p:sp>
-      <p:sp>
-        <p:nvSpPr>
-          <p:cNvPr id="9" name="Text 7"/>
-          <p:cNvSpPr/>
-          <p:nvPr/>
-        </p:nvSpPr>
-        <p:spPr>
-          <a:xfrm>
-            <a:off x="640080" y="4389120"/>
-            <a:ext cx="274320" cy="457200"/>
-          </a:xfrm>
-          <a:prstGeom prst="rect">
-            <a:avLst/>
-          </a:prstGeom>
-          <a:noFill/>
-          <a:ln/>
-        </p:spPr>
-        <p:txBody>
-          <a:bodyPr wrap="square" rtlCol="0" anchor="ctr"/>
-          <a:lstStyle/>
-          <a:p>
-            <a:pPr indent="0" marL="0">
-              <a:buNone/>
-            </a:pPr>
-            <a:r>
-              <a:rPr lang="en-US" sz="1600" b="1" dirty="0">
-                <a:solidFill>
-                  <a:srgbClr val="D97E3F"/>
-                </a:solidFill>
-              </a:rPr>
-              <a:t>•</a:t>
-            </a:r>
-            <a:endParaRPr lang="en-US" sz="1600" dirty="0"/>
-          </a:p>
-        </p:txBody>
-      </p:sp>
-      <p:sp>
-        <p:nvSpPr>
-          <p:cNvPr id="10" name="Text 8"/>
-          <p:cNvSpPr/>
-          <p:nvPr/>
-        </p:nvSpPr>
-        <p:spPr>
-          <a:xfrm>
-            <a:off x="960120" y="4389120"/>
-            <a:ext cx="9601200" cy="457200"/>
-          </a:xfrm>
-          <a:prstGeom prst="rect">
-            <a:avLst/>
-          </a:prstGeom>
-          <a:noFill/>
-          <a:ln/>
-        </p:spPr>
-        <p:txBody>
-          <a:bodyPr wrap="square" rtlCol="0" anchor="ctr"/>
-          <a:lstStyle/>
-          <a:p>
-            <a:pPr indent="0" marL="0">
-              <a:buNone/>
-            </a:pPr>
-            <a:r>
-              <a:rPr lang="en-US" sz="1500" dirty="0">
-                <a:solidFill>
-                  <a:srgbClr val="E8E8E8"/>
-                </a:solidFill>
-                <a:latin typeface="Calibri" pitchFamily="34" charset="0"/>
-                <a:ea typeface="Calibri" pitchFamily="34" charset="-122"/>
-                <a:cs typeface="Calibri" pitchFamily="34" charset="-120"/>
-              </a:rPr>
-              <a:t>Finished early? Go find a second, harder one.</a:t>
-            </a:r>
-            <a:endParaRPr lang="en-US" sz="1500" dirty="0"/>
-          </a:p>
-        </p:txBody>
-      </p:sp>
-    </p:spTree>
-  </p:cSld>
-  <p:clrMapOvr>
-    <a:masterClrMapping/>
-  </p:clrMapOvr>
-</p:sld>
-</file>
-
-<file path=ppt/slides/slide8.xml><?xml version="1.0" encoding="utf-8"?>
-<p:sld xmlns:a="http://schemas.openxmlformats.org/drawingml/2006/main" xmlns:r="http://schemas.openxmlformats.org/officeDocument/2006/relationships" xmlns:p="http://schemas.openxmlformats.org/presentationml/2006/main">
-  <p:cSld name="Slide 8">
-    <p:bg>
-      <p:bgPr>
-        <a:solidFill>
-          <a:srgbClr val="FFFFFF"/>
-        </a:solidFill>
-      </p:bgPr>
-    </p:bg>
-    <p:spTree>
-      <p:nvGrpSpPr>
-        <p:cNvPr id="1" name=""/>
-        <p:cNvGrpSpPr/>
-        <p:nvPr/>
-      </p:nvGrpSpPr>
-      <p:grpSpPr>
-        <a:xfrm>
-          <a:off x="0" y="0"/>
-          <a:ext cx="0" cy="0"/>
-          <a:chOff x="0" y="0"/>
-          <a:chExt cx="0" cy="0"/>
-        </a:xfrm>
-      </p:grpSpPr>
-      <p:sp>
-        <p:nvSpPr>
-          <p:cNvPr id="2" name="Text 0"/>
-          <p:cNvSpPr/>
-          <p:nvPr/>
-        </p:nvSpPr>
-        <p:spPr>
-          <a:xfrm>
-            <a:off x="640080" y="457200"/>
-            <a:ext cx="9144000" cy="365760"/>
-          </a:xfrm>
-          <a:prstGeom prst="rect">
-            <a:avLst/>
-          </a:prstGeom>
-          <a:noFill/>
-          <a:ln/>
-        </p:spPr>
-        <p:txBody>
-          <a:bodyPr wrap="square" rtlCol="0" anchor="ctr"/>
-          <a:lstStyle/>
-          <a:p>
-            <a:pPr indent="0" marL="0">
-              <a:buNone/>
-            </a:pPr>
-            <a:r>
-              <a:rPr lang="en-US" sz="1200" b="1" spc="200" kern="0" dirty="0">
-                <a:solidFill>
-                  <a:srgbClr val="D97E3F"/>
-                </a:solidFill>
-                <a:latin typeface="Calibri" pitchFamily="34" charset="0"/>
-                <a:ea typeface="Calibri" pitchFamily="34" charset="-122"/>
-                <a:cs typeface="Calibri" pitchFamily="34" charset="-120"/>
-              </a:rPr>
-              <a:t>NEXT WEEK</a:t>
-            </a:r>
-            <a:endParaRPr lang="en-US" sz="1200" dirty="0"/>
-          </a:p>
-        </p:txBody>
-      </p:sp>
-      <p:sp>
-        <p:nvSpPr>
-          <p:cNvPr id="3" name="Text 1"/>
-          <p:cNvSpPr/>
-          <p:nvPr/>
-        </p:nvSpPr>
-        <p:spPr>
-          <a:xfrm>
-            <a:off x="640080" y="777240"/>
-            <a:ext cx="10515600" cy="822960"/>
-          </a:xfrm>
-          <a:prstGeom prst="rect">
-            <a:avLst/>
-          </a:prstGeom>
-          <a:noFill/>
-          <a:ln/>
-        </p:spPr>
-        <p:txBody>
-          <a:bodyPr wrap="square" rtlCol="0" anchor="ctr"/>
-          <a:lstStyle/>
-          <a:p>
-            <a:pPr indent="0" marL="0">
-              <a:buNone/>
-            </a:pPr>
-            <a:r>
-              <a:rPr lang="en-US" sz="2700" b="1" dirty="0">
-                <a:solidFill>
-                  <a:srgbClr val="1B3A34"/>
-                </a:solidFill>
-                <a:latin typeface="Georgia" pitchFamily="34" charset="0"/>
-                <a:ea typeface="Georgia" pitchFamily="34" charset="-122"/>
-                <a:cs typeface="Georgia" pitchFamily="34" charset="-120"/>
-              </a:rPr>
-              <a:t>From spreadsheet to dashboard</a:t>
-            </a:r>
-            <a:endParaRPr lang="en-US" sz="2700" dirty="0"/>
-          </a:p>
-        </p:txBody>
-      </p:sp>
-      <p:sp>
-        <p:nvSpPr>
-          <p:cNvPr id="4" name="Text 2"/>
-          <p:cNvSpPr/>
-          <p:nvPr/>
-        </p:nvSpPr>
-        <p:spPr>
-          <a:xfrm>
-            <a:off x="640080" y="2103120"/>
-            <a:ext cx="10058400" cy="1097280"/>
-          </a:xfrm>
-          <a:prstGeom prst="rect">
-            <a:avLst/>
-          </a:prstGeom>
-          <a:noFill/>
-          <a:ln/>
-        </p:spPr>
-        <p:txBody>
-          <a:bodyPr wrap="square" rtlCol="0" anchor="ctr"/>
-          <a:lstStyle/>
-          <a:p>
-            <a:pPr indent="0" marL="0">
-              <a:buNone/>
-            </a:pPr>
-            <a:r>
-              <a:rPr lang="en-US" sz="2200" b="1" dirty="0">
-                <a:solidFill>
-                  <a:srgbClr val="1B3A34"/>
-                </a:solidFill>
-                <a:latin typeface="Georgia" pitchFamily="34" charset="0"/>
-                <a:ea typeface="Georgia" pitchFamily="34" charset="-122"/>
-                <a:cs typeface="Georgia" pitchFamily="34" charset="-120"/>
-              </a:rPr>
-              <a:t>Same dataset, Power BI this time — because a finding someone has to take your word for isn't a finding yet.</a:t>
-            </a:r>
-            <a:endParaRPr lang="en-US" sz="2200" dirty="0"/>
-          </a:p>
-        </p:txBody>
-      </p:sp>
-      <p:sp>
-        <p:nvSpPr>
-          <p:cNvPr id="5" name="Text 3"/>
-          <p:cNvSpPr/>
-          <p:nvPr/>
-        </p:nvSpPr>
-        <p:spPr>
-          <a:xfrm>
-            <a:off x="640080" y="3291840"/>
-            <a:ext cx="9875520" cy="731520"/>
-          </a:xfrm>
-          <a:prstGeom prst="rect">
-            <a:avLst/>
-          </a:prstGeom>
-          <a:noFill/>
-          <a:ln/>
-        </p:spPr>
-        <p:txBody>
-          <a:bodyPr wrap="square" rtlCol="0" anchor="ctr"/>
-          <a:lstStyle/>
-          <a:p>
-            <a:pPr indent="0" marL="0">
-              <a:buNone/>
-            </a:pPr>
-            <a:r>
-              <a:rPr lang="en-US" sz="1500" dirty="0">
-                <a:solidFill>
-                  <a:srgbClr val="2A2A2A"/>
-                </a:solidFill>
-                <a:latin typeface="Calibri" pitchFamily="34" charset="0"/>
-                <a:ea typeface="Calibri" pitchFamily="34" charset="-122"/>
-                <a:cs typeface="Calibri" pitchFamily="34" charset="-120"/>
-              </a:rPr>
-              <a:t>Bring whatever you built today — your engineered column carries forward.</a:t>
-            </a:r>
-            <a:endParaRPr lang="en-US" sz="1500" dirty="0"/>
-          </a:p>
-        </p:txBody>
-      </p:sp>
-      <p:sp>
-        <p:nvSpPr>
-          <p:cNvPr id="6" name="Text 4"/>
-          <p:cNvSpPr/>
-          <p:nvPr/>
-        </p:nvSpPr>
-        <p:spPr>
-          <a:xfrm>
-            <a:off x="640080" y="6035040"/>
-            <a:ext cx="7315200" cy="365760"/>
-          </a:xfrm>
-          <a:prstGeom prst="rect">
-            <a:avLst/>
-          </a:prstGeom>
-          <a:noFill/>
-          <a:ln/>
-        </p:spPr>
-        <p:txBody>
-          <a:bodyPr wrap="square" rtlCol="0" anchor="ctr"/>
-          <a:lstStyle/>
-          <a:p>
-            <a:pPr indent="0" marL="0">
-              <a:buNone/>
-            </a:pPr>
-            <a:r>
-              <a:rPr lang="en-US" sz="1100" b="1" spc="200" kern="0" dirty="0">
-                <a:solidFill>
-                  <a:srgbClr val="6B6B6B"/>
-                </a:solidFill>
-                <a:latin typeface="Calibri" pitchFamily="34" charset="0"/>
-                <a:ea typeface="Calibri" pitchFamily="34" charset="-122"/>
-                <a:cs typeface="Calibri" pitchFamily="34" charset="-120"/>
-              </a:rPr>
-              <a:t>DSDG DATA ANALYTICS</a:t>
-            </a:r>
-            <a:endParaRPr lang="en-US" sz="1100" dirty="0"/>
           </a:p>
         </p:txBody>
       </p:sp>

</xml_diff>